<commit_message>
Doc and image updates
</commit_message>
<xml_diff>
--- a/releases/15_MLRws/docs/gridstation/MLR_Grid_diagrams.pptx
+++ b/releases/15_MLRws/docs/gridstation/MLR_Grid_diagrams.pptx
@@ -8,10 +8,13 @@
     <p:sldId id="259" r:id="rId2"/>
     <p:sldId id="257" r:id="rId3"/>
     <p:sldId id="263" r:id="rId4"/>
-    <p:sldId id="258" r:id="rId5"/>
-    <p:sldId id="260" r:id="rId6"/>
-    <p:sldId id="262" r:id="rId7"/>
-    <p:sldId id="261" r:id="rId8"/>
+    <p:sldId id="266" r:id="rId5"/>
+    <p:sldId id="258" r:id="rId6"/>
+    <p:sldId id="260" r:id="rId7"/>
+    <p:sldId id="264" r:id="rId8"/>
+    <p:sldId id="262" r:id="rId9"/>
+    <p:sldId id="261" r:id="rId10"/>
+    <p:sldId id="265" r:id="rId11"/>
   </p:sldIdLst>
   <p:sldSz cx="12192000" cy="6858000"/>
   <p:notesSz cx="6858000" cy="9144000"/>
@@ -110,6 +113,11 @@
       </a:defRPr>
     </a:lvl9pPr>
   </p:defaultTextStyle>
+  <p:extLst>
+    <p:ext uri="{EFAFB233-063F-42B5-8137-9DF3F51BA10A}">
+      <p15:sldGuideLst xmlns:p15="http://schemas.microsoft.com/office/powerpoint/2012/main"/>
+    </p:ext>
+  </p:extLst>
 </p:presentation>
 </file>
 
@@ -260,7 +268,7 @@
           <a:p>
             <a:fld id="{ED31DEDB-43A4-F744-A550-DF85E4DC1635}" type="datetimeFigureOut">
               <a:rPr lang="en-US" smtClean="0"/>
-              <a:t>4/27/26</a:t>
+              <a:t>5/26/26</a:t>
             </a:fld>
             <a:endParaRPr lang="en-US"/>
           </a:p>
@@ -458,7 +466,7 @@
           <a:p>
             <a:fld id="{ED31DEDB-43A4-F744-A550-DF85E4DC1635}" type="datetimeFigureOut">
               <a:rPr lang="en-US" smtClean="0"/>
-              <a:t>4/27/26</a:t>
+              <a:t>5/26/26</a:t>
             </a:fld>
             <a:endParaRPr lang="en-US"/>
           </a:p>
@@ -666,7 +674,7 @@
           <a:p>
             <a:fld id="{ED31DEDB-43A4-F744-A550-DF85E4DC1635}" type="datetimeFigureOut">
               <a:rPr lang="en-US" smtClean="0"/>
-              <a:t>4/27/26</a:t>
+              <a:t>5/26/26</a:t>
             </a:fld>
             <a:endParaRPr lang="en-US"/>
           </a:p>
@@ -864,7 +872,7 @@
           <a:p>
             <a:fld id="{ED31DEDB-43A4-F744-A550-DF85E4DC1635}" type="datetimeFigureOut">
               <a:rPr lang="en-US" smtClean="0"/>
-              <a:t>4/27/26</a:t>
+              <a:t>5/26/26</a:t>
             </a:fld>
             <a:endParaRPr lang="en-US"/>
           </a:p>
@@ -1139,7 +1147,7 @@
           <a:p>
             <a:fld id="{ED31DEDB-43A4-F744-A550-DF85E4DC1635}" type="datetimeFigureOut">
               <a:rPr lang="en-US" smtClean="0"/>
-              <a:t>4/27/26</a:t>
+              <a:t>5/26/26</a:t>
             </a:fld>
             <a:endParaRPr lang="en-US"/>
           </a:p>
@@ -1404,7 +1412,7 @@
           <a:p>
             <a:fld id="{ED31DEDB-43A4-F744-A550-DF85E4DC1635}" type="datetimeFigureOut">
               <a:rPr lang="en-US" smtClean="0"/>
-              <a:t>4/27/26</a:t>
+              <a:t>5/26/26</a:t>
             </a:fld>
             <a:endParaRPr lang="en-US"/>
           </a:p>
@@ -1816,7 +1824,7 @@
           <a:p>
             <a:fld id="{ED31DEDB-43A4-F744-A550-DF85E4DC1635}" type="datetimeFigureOut">
               <a:rPr lang="en-US" smtClean="0"/>
-              <a:t>4/27/26</a:t>
+              <a:t>5/26/26</a:t>
             </a:fld>
             <a:endParaRPr lang="en-US"/>
           </a:p>
@@ -1957,7 +1965,7 @@
           <a:p>
             <a:fld id="{ED31DEDB-43A4-F744-A550-DF85E4DC1635}" type="datetimeFigureOut">
               <a:rPr lang="en-US" smtClean="0"/>
-              <a:t>4/27/26</a:t>
+              <a:t>5/26/26</a:t>
             </a:fld>
             <a:endParaRPr lang="en-US"/>
           </a:p>
@@ -2070,7 +2078,7 @@
           <a:p>
             <a:fld id="{ED31DEDB-43A4-F744-A550-DF85E4DC1635}" type="datetimeFigureOut">
               <a:rPr lang="en-US" smtClean="0"/>
-              <a:t>4/27/26</a:t>
+              <a:t>5/26/26</a:t>
             </a:fld>
             <a:endParaRPr lang="en-US"/>
           </a:p>
@@ -2381,7 +2389,7 @@
           <a:p>
             <a:fld id="{ED31DEDB-43A4-F744-A550-DF85E4DC1635}" type="datetimeFigureOut">
               <a:rPr lang="en-US" smtClean="0"/>
-              <a:t>4/27/26</a:t>
+              <a:t>5/26/26</a:t>
             </a:fld>
             <a:endParaRPr lang="en-US"/>
           </a:p>
@@ -2669,7 +2677,7 @@
           <a:p>
             <a:fld id="{ED31DEDB-43A4-F744-A550-DF85E4DC1635}" type="datetimeFigureOut">
               <a:rPr lang="en-US" smtClean="0"/>
-              <a:t>4/27/26</a:t>
+              <a:t>5/26/26</a:t>
             </a:fld>
             <a:endParaRPr lang="en-US"/>
           </a:p>
@@ -2910,7 +2918,7 @@
           <a:p>
             <a:fld id="{ED31DEDB-43A4-F744-A550-DF85E4DC1635}" type="datetimeFigureOut">
               <a:rPr lang="en-US" smtClean="0"/>
-              <a:t>4/27/26</a:t>
+              <a:t>5/26/26</a:t>
             </a:fld>
             <a:endParaRPr lang="en-US"/>
           </a:p>
@@ -3333,6 +3341,36 @@
           <a:chExt cx="0" cy="0"/>
         </a:xfrm>
       </p:grpSpPr>
+      <p:pic>
+        <p:nvPicPr>
+          <p:cNvPr id="4" name="Picture 3">
+            <a:extLst>
+              <a:ext uri="{FF2B5EF4-FFF2-40B4-BE49-F238E27FC236}">
+                <a16:creationId xmlns:a16="http://schemas.microsoft.com/office/drawing/2014/main" id="{773B5DA2-0D7D-A2E7-C6B8-54D421848BC1}"/>
+              </a:ext>
+            </a:extLst>
+          </p:cNvPr>
+          <p:cNvPicPr>
+            <a:picLocks noChangeAspect="1"/>
+          </p:cNvPicPr>
+          <p:nvPr/>
+        </p:nvPicPr>
+        <p:blipFill>
+          <a:blip r:embed="rId2"/>
+          <a:stretch>
+            <a:fillRect/>
+          </a:stretch>
+        </p:blipFill>
+        <p:spPr>
+          <a:xfrm>
+            <a:off x="2197100" y="1682480"/>
+            <a:ext cx="7772400" cy="4216940"/>
+          </a:xfrm>
+          <a:prstGeom prst="rect">
+            <a:avLst/>
+          </a:prstGeom>
+        </p:spPr>
+      </p:pic>
       <p:sp>
         <p:nvSpPr>
           <p:cNvPr id="5" name="Title 1">
@@ -3380,10 +3418,10 @@
         </p:nvGrpSpPr>
         <p:grpSpPr>
           <a:xfrm>
-            <a:off x="750849" y="1536340"/>
-            <a:ext cx="10690302" cy="4614448"/>
-            <a:chOff x="750849" y="1536340"/>
-            <a:chExt cx="10690302" cy="4614448"/>
+            <a:off x="2352139" y="1536340"/>
+            <a:ext cx="7249067" cy="4614448"/>
+            <a:chOff x="2352139" y="1536340"/>
+            <a:chExt cx="7249067" cy="4614448"/>
           </a:xfrm>
         </p:grpSpPr>
         <p:grpSp>
@@ -3400,42 +3438,12 @@
           </p:nvGrpSpPr>
           <p:grpSpPr>
             <a:xfrm>
-              <a:off x="2209800" y="1690688"/>
-              <a:ext cx="7772400" cy="4210541"/>
-              <a:chOff x="1984562" y="1690688"/>
-              <a:chExt cx="7772400" cy="4210541"/>
+              <a:off x="2574737" y="2044700"/>
+              <a:ext cx="7026469" cy="3572328"/>
+              <a:chOff x="2349499" y="2044700"/>
+              <a:chExt cx="7026469" cy="3572328"/>
             </a:xfrm>
           </p:grpSpPr>
-          <p:pic>
-            <p:nvPicPr>
-              <p:cNvPr id="2" name="Picture 1" descr="A grid of squares with different colors&#10;&#10;AI-generated content may be incorrect.">
-                <a:extLst>
-                  <a:ext uri="{FF2B5EF4-FFF2-40B4-BE49-F238E27FC236}">
-                    <a16:creationId xmlns:a16="http://schemas.microsoft.com/office/drawing/2014/main" id="{02C7B0C8-23FD-B139-50B6-7C7A5DD959F5}"/>
-                  </a:ext>
-                </a:extLst>
-              </p:cNvPr>
-              <p:cNvPicPr>
-                <a:picLocks noChangeAspect="1"/>
-              </p:cNvPicPr>
-              <p:nvPr/>
-            </p:nvPicPr>
-            <p:blipFill>
-              <a:blip r:embed="rId2"/>
-              <a:stretch>
-                <a:fillRect/>
-              </a:stretch>
-            </p:blipFill>
-            <p:spPr>
-              <a:xfrm>
-                <a:off x="1984562" y="1690688"/>
-                <a:ext cx="7772400" cy="4210541"/>
-              </a:xfrm>
-              <a:prstGeom prst="rect">
-                <a:avLst/>
-              </a:prstGeom>
-            </p:spPr>
-          </p:pic>
           <p:sp>
             <p:nvSpPr>
               <p:cNvPr id="3" name="Rectangle 2">
@@ -3542,58 +3550,6 @@
           </p:sp>
           <p:sp>
             <p:nvSpPr>
-              <p:cNvPr id="7" name="Rectangle 6">
-                <a:extLst>
-                  <a:ext uri="{FF2B5EF4-FFF2-40B4-BE49-F238E27FC236}">
-                    <a16:creationId xmlns:a16="http://schemas.microsoft.com/office/drawing/2014/main" id="{5083458D-BFF9-759D-EFA9-9F6494F0EE98}"/>
-                  </a:ext>
-                </a:extLst>
-              </p:cNvPr>
-              <p:cNvSpPr/>
-              <p:nvPr/>
-            </p:nvSpPr>
-            <p:spPr>
-              <a:xfrm>
-                <a:off x="2349500" y="2501900"/>
-                <a:ext cx="455168" cy="2657929"/>
-              </a:xfrm>
-              <a:prstGeom prst="rect">
-                <a:avLst/>
-              </a:prstGeom>
-              <a:noFill/>
-              <a:ln w="38100">
-                <a:solidFill>
-                  <a:schemeClr val="accent3"/>
-                </a:solidFill>
-              </a:ln>
-            </p:spPr>
-            <p:style>
-              <a:lnRef idx="2">
-                <a:schemeClr val="accent1">
-                  <a:shade val="15000"/>
-                </a:schemeClr>
-              </a:lnRef>
-              <a:fillRef idx="1">
-                <a:schemeClr val="accent1"/>
-              </a:fillRef>
-              <a:effectRef idx="0">
-                <a:schemeClr val="accent1"/>
-              </a:effectRef>
-              <a:fontRef idx="minor">
-                <a:schemeClr val="lt1"/>
-              </a:fontRef>
-            </p:style>
-            <p:txBody>
-              <a:bodyPr rtlCol="0" anchor="ctr"/>
-              <a:lstStyle/>
-              <a:p>
-                <a:pPr algn="ctr"/>
-                <a:endParaRPr lang="en-US"/>
-              </a:p>
-            </p:txBody>
-          </p:sp>
-          <p:sp>
-            <p:nvSpPr>
               <p:cNvPr id="8" name="Rectangle 7">
                 <a:extLst>
                   <a:ext uri="{FF2B5EF4-FFF2-40B4-BE49-F238E27FC236}">
@@ -3608,58 +3564,6 @@
               <a:xfrm>
                 <a:off x="6286500" y="2070100"/>
                 <a:ext cx="1765300" cy="457200"/>
-              </a:xfrm>
-              <a:prstGeom prst="rect">
-                <a:avLst/>
-              </a:prstGeom>
-              <a:noFill/>
-              <a:ln w="38100">
-                <a:solidFill>
-                  <a:schemeClr val="accent3"/>
-                </a:solidFill>
-              </a:ln>
-            </p:spPr>
-            <p:style>
-              <a:lnRef idx="2">
-                <a:schemeClr val="accent1">
-                  <a:shade val="15000"/>
-                </a:schemeClr>
-              </a:lnRef>
-              <a:fillRef idx="1">
-                <a:schemeClr val="accent1"/>
-              </a:fillRef>
-              <a:effectRef idx="0">
-                <a:schemeClr val="accent1"/>
-              </a:effectRef>
-              <a:fontRef idx="minor">
-                <a:schemeClr val="lt1"/>
-              </a:fontRef>
-            </p:style>
-            <p:txBody>
-              <a:bodyPr rtlCol="0" anchor="ctr"/>
-              <a:lstStyle/>
-              <a:p>
-                <a:pPr algn="ctr"/>
-                <a:endParaRPr lang="en-US"/>
-              </a:p>
-            </p:txBody>
-          </p:sp>
-          <p:sp>
-            <p:nvSpPr>
-              <p:cNvPr id="9" name="Rectangle 8">
-                <a:extLst>
-                  <a:ext uri="{FF2B5EF4-FFF2-40B4-BE49-F238E27FC236}">
-                    <a16:creationId xmlns:a16="http://schemas.microsoft.com/office/drawing/2014/main" id="{7D369EA8-6313-5D28-7D0D-1F008B7E07DE}"/>
-                  </a:ext>
-                </a:extLst>
-              </p:cNvPr>
-              <p:cNvSpPr/>
-              <p:nvPr/>
-            </p:nvSpPr>
-            <p:spPr>
-              <a:xfrm>
-                <a:off x="8920801" y="2527300"/>
-                <a:ext cx="455168" cy="2632528"/>
               </a:xfrm>
               <a:prstGeom prst="rect">
                 <a:avLst/>
@@ -3815,8 +3719,8 @@
           </p:nvSpPr>
           <p:spPr>
             <a:xfrm>
-              <a:off x="3029906" y="2527300"/>
-              <a:ext cx="6112067" cy="2607128"/>
+              <a:off x="2574738" y="2527300"/>
+              <a:ext cx="7026468" cy="2607128"/>
             </a:xfrm>
             <a:prstGeom prst="rect">
               <a:avLst/>
@@ -3955,7 +3859,7 @@
             <a:p>
               <a:r>
                 <a:rPr lang="en-US" dirty="0"/>
-                <a:t>Scenes</a:t>
+                <a:t>Recalls</a:t>
               </a:r>
             </a:p>
           </p:txBody>
@@ -3991,77 +3895,6 @@
               <a:r>
                 <a:rPr lang="en-US" dirty="0"/>
                 <a:t>Delete</a:t>
-              </a:r>
-            </a:p>
-          </p:txBody>
-        </p:sp>
-        <p:sp>
-          <p:nvSpPr>
-            <p:cNvPr id="18" name="TextBox 17">
-              <a:extLst>
-                <a:ext uri="{FF2B5EF4-FFF2-40B4-BE49-F238E27FC236}">
-                  <a16:creationId xmlns:a16="http://schemas.microsoft.com/office/drawing/2014/main" id="{D070E7EC-562B-9295-B63A-82237419D3FF}"/>
-                </a:ext>
-              </a:extLst>
-            </p:cNvPr>
-            <p:cNvSpPr txBox="1"/>
-            <p:nvPr/>
-          </p:nvSpPr>
-          <p:spPr>
-            <a:xfrm>
-              <a:off x="9832457" y="3195793"/>
-              <a:ext cx="1608694" cy="1200329"/>
-            </a:xfrm>
-            <a:prstGeom prst="rect">
-              <a:avLst/>
-            </a:prstGeom>
-            <a:noFill/>
-          </p:spPr>
-          <p:txBody>
-            <a:bodyPr wrap="square" rtlCol="0">
-              <a:spAutoFit/>
-            </a:bodyPr>
-            <a:lstStyle/>
-            <a:p>
-              <a:r>
-                <a:rPr lang="en-US" dirty="0"/>
-                <a:t>Toggle playback (hold for gated playback)</a:t>
-              </a:r>
-            </a:p>
-          </p:txBody>
-        </p:sp>
-        <p:sp>
-          <p:nvSpPr>
-            <p:cNvPr id="19" name="TextBox 18">
-              <a:extLst>
-                <a:ext uri="{FF2B5EF4-FFF2-40B4-BE49-F238E27FC236}">
-                  <a16:creationId xmlns:a16="http://schemas.microsoft.com/office/drawing/2014/main" id="{3D73F38D-477E-63CA-0C65-C5126F613247}"/>
-                </a:ext>
-              </a:extLst>
-            </p:cNvPr>
-            <p:cNvSpPr txBox="1"/>
-            <p:nvPr/>
-          </p:nvSpPr>
-          <p:spPr>
-            <a:xfrm>
-              <a:off x="750849" y="3472791"/>
-              <a:ext cx="1608694" cy="646331"/>
-            </a:xfrm>
-            <a:prstGeom prst="rect">
-              <a:avLst/>
-            </a:prstGeom>
-            <a:noFill/>
-          </p:spPr>
-          <p:txBody>
-            <a:bodyPr wrap="square" rtlCol="0">
-              <a:spAutoFit/>
-            </a:bodyPr>
-            <a:lstStyle/>
-            <a:p>
-              <a:pPr algn="r"/>
-              <a:r>
-                <a:rPr lang="en-US" dirty="0"/>
-                <a:t>Arm for recording</a:t>
               </a:r>
             </a:p>
           </p:txBody>
@@ -4116,6 +3949,426 @@
 </p:sld>
 </file>
 
+<file path=ppt/slides/slide10.xml><?xml version="1.0" encoding="utf-8"?>
+<p:sld xmlns:a="http://schemas.openxmlformats.org/drawingml/2006/main" xmlns:r="http://schemas.openxmlformats.org/officeDocument/2006/relationships" xmlns:p="http://schemas.openxmlformats.org/presentationml/2006/main">
+  <p:cSld>
+    <p:spTree>
+      <p:nvGrpSpPr>
+        <p:cNvPr id="1" name="">
+          <a:extLst>
+            <a:ext uri="{FF2B5EF4-FFF2-40B4-BE49-F238E27FC236}">
+              <a16:creationId xmlns:a16="http://schemas.microsoft.com/office/drawing/2014/main" id="{FB3FE4D2-081F-5692-32C1-CB92A930F00C}"/>
+            </a:ext>
+          </a:extLst>
+        </p:cNvPr>
+        <p:cNvGrpSpPr/>
+        <p:nvPr/>
+      </p:nvGrpSpPr>
+      <p:grpSpPr>
+        <a:xfrm>
+          <a:off x="0" y="0"/>
+          <a:ext cx="0" cy="0"/>
+          <a:chOff x="0" y="0"/>
+          <a:chExt cx="0" cy="0"/>
+        </a:xfrm>
+      </p:grpSpPr>
+      <p:pic>
+        <p:nvPicPr>
+          <p:cNvPr id="6" name="Picture 5">
+            <a:extLst>
+              <a:ext uri="{FF2B5EF4-FFF2-40B4-BE49-F238E27FC236}">
+                <a16:creationId xmlns:a16="http://schemas.microsoft.com/office/drawing/2014/main" id="{F61637B8-8920-2C56-00BB-B345B8C845A7}"/>
+              </a:ext>
+            </a:extLst>
+          </p:cNvPr>
+          <p:cNvPicPr>
+            <a:picLocks noChangeAspect="1"/>
+          </p:cNvPicPr>
+          <p:nvPr/>
+        </p:nvPicPr>
+        <p:blipFill>
+          <a:blip r:embed="rId2"/>
+          <a:stretch>
+            <a:fillRect/>
+          </a:stretch>
+        </p:blipFill>
+        <p:spPr>
+          <a:xfrm>
+            <a:off x="2387600" y="1695180"/>
+            <a:ext cx="7772400" cy="4216940"/>
+          </a:xfrm>
+          <a:prstGeom prst="rect">
+            <a:avLst/>
+          </a:prstGeom>
+        </p:spPr>
+      </p:pic>
+      <p:sp>
+        <p:nvSpPr>
+          <p:cNvPr id="2" name="Title 1">
+            <a:extLst>
+              <a:ext uri="{FF2B5EF4-FFF2-40B4-BE49-F238E27FC236}">
+                <a16:creationId xmlns:a16="http://schemas.microsoft.com/office/drawing/2014/main" id="{1C9A7CFD-B67A-7370-C82E-D0471ED24E9A}"/>
+              </a:ext>
+            </a:extLst>
+          </p:cNvPr>
+          <p:cNvSpPr>
+            <a:spLocks noGrp="1"/>
+          </p:cNvSpPr>
+          <p:nvPr>
+            <p:ph type="title"/>
+          </p:nvPr>
+        </p:nvSpPr>
+        <p:spPr/>
+        <p:txBody>
+          <a:bodyPr/>
+          <a:lstStyle/>
+          <a:p>
+            <a:r>
+              <a:rPr lang="en-US" dirty="0"/>
+              <a:t>REC page</a:t>
+            </a:r>
+          </a:p>
+        </p:txBody>
+      </p:sp>
+      <p:grpSp>
+        <p:nvGrpSpPr>
+          <p:cNvPr id="9" name="Group 8">
+            <a:extLst>
+              <a:ext uri="{FF2B5EF4-FFF2-40B4-BE49-F238E27FC236}">
+                <a16:creationId xmlns:a16="http://schemas.microsoft.com/office/drawing/2014/main" id="{53DA5F69-4868-C053-931A-D767D39837B2}"/>
+              </a:ext>
+            </a:extLst>
+          </p:cNvPr>
+          <p:cNvGrpSpPr/>
+          <p:nvPr/>
+        </p:nvGrpSpPr>
+        <p:grpSpPr>
+          <a:xfrm>
+            <a:off x="2761784" y="1502472"/>
+            <a:ext cx="7626816" cy="4103503"/>
+            <a:chOff x="2761784" y="1502472"/>
+            <a:chExt cx="7626816" cy="4103503"/>
+          </a:xfrm>
+        </p:grpSpPr>
+        <p:grpSp>
+          <p:nvGrpSpPr>
+            <p:cNvPr id="30" name="Group 29">
+              <a:extLst>
+                <a:ext uri="{FF2B5EF4-FFF2-40B4-BE49-F238E27FC236}">
+                  <a16:creationId xmlns:a16="http://schemas.microsoft.com/office/drawing/2014/main" id="{1BC7A7D3-F3BE-4761-3256-E6831A97339F}"/>
+                </a:ext>
+              </a:extLst>
+            </p:cNvPr>
+            <p:cNvGrpSpPr/>
+            <p:nvPr/>
+          </p:nvGrpSpPr>
+          <p:grpSpPr>
+            <a:xfrm>
+              <a:off x="2761784" y="2048428"/>
+              <a:ext cx="7012021" cy="3557547"/>
+              <a:chOff x="2761784" y="2048428"/>
+              <a:chExt cx="7012021" cy="3557547"/>
+            </a:xfrm>
+          </p:grpSpPr>
+          <p:sp>
+            <p:nvSpPr>
+              <p:cNvPr id="21" name="Rectangle 20">
+                <a:extLst>
+                  <a:ext uri="{FF2B5EF4-FFF2-40B4-BE49-F238E27FC236}">
+                    <a16:creationId xmlns:a16="http://schemas.microsoft.com/office/drawing/2014/main" id="{B272C624-884E-26C6-5994-0651AD7CCA64}"/>
+                  </a:ext>
+                </a:extLst>
+              </p:cNvPr>
+              <p:cNvSpPr/>
+              <p:nvPr/>
+            </p:nvSpPr>
+            <p:spPr>
+              <a:xfrm>
+                <a:off x="2761784" y="2048428"/>
+                <a:ext cx="7006685" cy="461226"/>
+              </a:xfrm>
+              <a:prstGeom prst="rect">
+                <a:avLst/>
+              </a:prstGeom>
+              <a:solidFill>
+                <a:srgbClr val="7F7F7F">
+                  <a:alpha val="50196"/>
+                </a:srgbClr>
+              </a:solidFill>
+              <a:ln>
+                <a:noFill/>
+              </a:ln>
+            </p:spPr>
+            <p:style>
+              <a:lnRef idx="2">
+                <a:schemeClr val="accent1">
+                  <a:shade val="15000"/>
+                </a:schemeClr>
+              </a:lnRef>
+              <a:fillRef idx="1">
+                <a:schemeClr val="accent1"/>
+              </a:fillRef>
+              <a:effectRef idx="0">
+                <a:schemeClr val="accent1"/>
+              </a:effectRef>
+              <a:fontRef idx="minor">
+                <a:schemeClr val="lt1"/>
+              </a:fontRef>
+            </p:style>
+            <p:txBody>
+              <a:bodyPr rtlCol="0" anchor="ctr"/>
+              <a:lstStyle/>
+              <a:p>
+                <a:pPr algn="ctr"/>
+                <a:endParaRPr lang="en-US" dirty="0"/>
+              </a:p>
+            </p:txBody>
+          </p:sp>
+          <p:sp>
+            <p:nvSpPr>
+              <p:cNvPr id="22" name="Rectangle 21">
+                <a:extLst>
+                  <a:ext uri="{FF2B5EF4-FFF2-40B4-BE49-F238E27FC236}">
+                    <a16:creationId xmlns:a16="http://schemas.microsoft.com/office/drawing/2014/main" id="{0C77BA24-9400-B0D0-BB51-418227B781EC}"/>
+                  </a:ext>
+                </a:extLst>
+              </p:cNvPr>
+              <p:cNvSpPr/>
+              <p:nvPr/>
+            </p:nvSpPr>
+            <p:spPr>
+              <a:xfrm>
+                <a:off x="2761785" y="5185316"/>
+                <a:ext cx="7006683" cy="420659"/>
+              </a:xfrm>
+              <a:prstGeom prst="rect">
+                <a:avLst/>
+              </a:prstGeom>
+              <a:solidFill>
+                <a:srgbClr val="7F7F7F">
+                  <a:alpha val="50196"/>
+                </a:srgbClr>
+              </a:solidFill>
+              <a:ln>
+                <a:noFill/>
+              </a:ln>
+            </p:spPr>
+            <p:style>
+              <a:lnRef idx="2">
+                <a:schemeClr val="accent1">
+                  <a:shade val="15000"/>
+                </a:schemeClr>
+              </a:lnRef>
+              <a:fillRef idx="1">
+                <a:schemeClr val="accent1"/>
+              </a:fillRef>
+              <a:effectRef idx="0">
+                <a:schemeClr val="accent1"/>
+              </a:effectRef>
+              <a:fontRef idx="minor">
+                <a:schemeClr val="lt1"/>
+              </a:fontRef>
+            </p:style>
+            <p:txBody>
+              <a:bodyPr rtlCol="0" anchor="ctr"/>
+              <a:lstStyle/>
+              <a:p>
+                <a:pPr algn="ctr"/>
+                <a:endParaRPr lang="en-US"/>
+              </a:p>
+            </p:txBody>
+          </p:sp>
+          <p:sp>
+            <p:nvSpPr>
+              <p:cNvPr id="24" name="Rectangle 23">
+                <a:extLst>
+                  <a:ext uri="{FF2B5EF4-FFF2-40B4-BE49-F238E27FC236}">
+                    <a16:creationId xmlns:a16="http://schemas.microsoft.com/office/drawing/2014/main" id="{872CF716-3B17-9DF2-E416-7A249F727092}"/>
+                  </a:ext>
+                </a:extLst>
+              </p:cNvPr>
+              <p:cNvSpPr/>
+              <p:nvPr/>
+            </p:nvSpPr>
+            <p:spPr>
+              <a:xfrm>
+                <a:off x="2761784" y="2509654"/>
+                <a:ext cx="6560282" cy="2675661"/>
+              </a:xfrm>
+              <a:prstGeom prst="rect">
+                <a:avLst/>
+              </a:prstGeom>
+              <a:solidFill>
+                <a:srgbClr val="7F7F7F">
+                  <a:alpha val="50196"/>
+                </a:srgbClr>
+              </a:solidFill>
+              <a:ln>
+                <a:noFill/>
+              </a:ln>
+            </p:spPr>
+            <p:style>
+              <a:lnRef idx="2">
+                <a:schemeClr val="accent1">
+                  <a:shade val="15000"/>
+                </a:schemeClr>
+              </a:lnRef>
+              <a:fillRef idx="1">
+                <a:schemeClr val="accent1"/>
+              </a:fillRef>
+              <a:effectRef idx="0">
+                <a:schemeClr val="accent1"/>
+              </a:effectRef>
+              <a:fontRef idx="minor">
+                <a:schemeClr val="lt1"/>
+              </a:fontRef>
+            </p:style>
+            <p:txBody>
+              <a:bodyPr rtlCol="0" anchor="ctr"/>
+              <a:lstStyle/>
+              <a:p>
+                <a:pPr algn="ctr"/>
+                <a:endParaRPr lang="en-US" dirty="0"/>
+              </a:p>
+            </p:txBody>
+          </p:sp>
+          <p:sp>
+            <p:nvSpPr>
+              <p:cNvPr id="26" name="Rectangle 25">
+                <a:extLst>
+                  <a:ext uri="{FF2B5EF4-FFF2-40B4-BE49-F238E27FC236}">
+                    <a16:creationId xmlns:a16="http://schemas.microsoft.com/office/drawing/2014/main" id="{E8F51A9C-0C39-C9CF-A9EA-88576B6F2AD5}"/>
+                  </a:ext>
+                </a:extLst>
+              </p:cNvPr>
+              <p:cNvSpPr/>
+              <p:nvPr/>
+            </p:nvSpPr>
+            <p:spPr>
+              <a:xfrm>
+                <a:off x="9327403" y="2515076"/>
+                <a:ext cx="446402" cy="2664017"/>
+              </a:xfrm>
+              <a:prstGeom prst="rect">
+                <a:avLst/>
+              </a:prstGeom>
+              <a:noFill/>
+              <a:ln w="38100">
+                <a:solidFill>
+                  <a:schemeClr val="accent5"/>
+                </a:solidFill>
+              </a:ln>
+            </p:spPr>
+            <p:style>
+              <a:lnRef idx="2">
+                <a:schemeClr val="accent1">
+                  <a:shade val="15000"/>
+                </a:schemeClr>
+              </a:lnRef>
+              <a:fillRef idx="1">
+                <a:schemeClr val="accent1"/>
+              </a:fillRef>
+              <a:effectRef idx="0">
+                <a:schemeClr val="accent1"/>
+              </a:effectRef>
+              <a:fontRef idx="minor">
+                <a:schemeClr val="lt1"/>
+              </a:fontRef>
+            </p:style>
+            <p:txBody>
+              <a:bodyPr rtlCol="0" anchor="ctr"/>
+              <a:lstStyle/>
+              <a:p>
+                <a:pPr algn="ctr"/>
+                <a:endParaRPr lang="en-US" dirty="0"/>
+              </a:p>
+            </p:txBody>
+          </p:sp>
+        </p:grpSp>
+        <p:sp>
+          <p:nvSpPr>
+            <p:cNvPr id="3" name="TextBox 2">
+              <a:extLst>
+                <a:ext uri="{FF2B5EF4-FFF2-40B4-BE49-F238E27FC236}">
+                  <a16:creationId xmlns:a16="http://schemas.microsoft.com/office/drawing/2014/main" id="{611141DF-D8A9-C9B7-2F5C-541375329714}"/>
+                </a:ext>
+              </a:extLst>
+            </p:cNvPr>
+            <p:cNvSpPr txBox="1"/>
+            <p:nvPr/>
+          </p:nvSpPr>
+          <p:spPr>
+            <a:xfrm>
+              <a:off x="8559799" y="1502472"/>
+              <a:ext cx="1828801" cy="369332"/>
+            </a:xfrm>
+            <a:prstGeom prst="rect">
+              <a:avLst/>
+            </a:prstGeom>
+            <a:noFill/>
+          </p:spPr>
+          <p:txBody>
+            <a:bodyPr wrap="square" rtlCol="0">
+              <a:spAutoFit/>
+            </a:bodyPr>
+            <a:lstStyle/>
+            <a:p>
+              <a:r>
+                <a:rPr lang="en-US" dirty="0"/>
+                <a:t>Toggle playback</a:t>
+              </a:r>
+            </a:p>
+          </p:txBody>
+        </p:sp>
+      </p:grpSp>
+      <p:sp>
+        <p:nvSpPr>
+          <p:cNvPr id="5" name="TextBox 4">
+            <a:extLst>
+              <a:ext uri="{FF2B5EF4-FFF2-40B4-BE49-F238E27FC236}">
+                <a16:creationId xmlns:a16="http://schemas.microsoft.com/office/drawing/2014/main" id="{9E11A2FF-E47C-3EDC-4B8E-5256495E0DBF}"/>
+              </a:ext>
+            </a:extLst>
+          </p:cNvPr>
+          <p:cNvSpPr txBox="1"/>
+          <p:nvPr/>
+        </p:nvSpPr>
+        <p:spPr>
+          <a:xfrm>
+            <a:off x="8636203" y="5822365"/>
+            <a:ext cx="1828801" cy="646331"/>
+          </a:xfrm>
+          <a:prstGeom prst="rect">
+            <a:avLst/>
+          </a:prstGeom>
+          <a:noFill/>
+        </p:spPr>
+        <p:txBody>
+          <a:bodyPr wrap="square" rtlCol="0">
+            <a:spAutoFit/>
+          </a:bodyPr>
+          <a:lstStyle/>
+          <a:p>
+            <a:r>
+              <a:rPr lang="en-US" dirty="0"/>
+              <a:t>Hold to toggle gated playback</a:t>
+            </a:r>
+          </a:p>
+        </p:txBody>
+      </p:sp>
+    </p:spTree>
+    <p:extLst>
+      <p:ext uri="{BB962C8B-B14F-4D97-AF65-F5344CB8AC3E}">
+        <p14:creationId xmlns:p14="http://schemas.microsoft.com/office/powerpoint/2010/main" val="1132530611"/>
+      </p:ext>
+    </p:extLst>
+  </p:cSld>
+  <p:clrMapOvr>
+    <a:masterClrMapping/>
+  </p:clrMapOvr>
+</p:sld>
+</file>
+
 <file path=ppt/slides/slide2.xml><?xml version="1.0" encoding="utf-8"?>
 <p:sld xmlns:a="http://schemas.openxmlformats.org/drawingml/2006/main" xmlns:r="http://schemas.openxmlformats.org/officeDocument/2006/relationships" xmlns:p="http://schemas.openxmlformats.org/presentationml/2006/main">
   <p:cSld>
@@ -4133,6 +4386,36 @@
           <a:chExt cx="0" cy="0"/>
         </a:xfrm>
       </p:grpSpPr>
+      <p:pic>
+        <p:nvPicPr>
+          <p:cNvPr id="2" name="Picture 1">
+            <a:extLst>
+              <a:ext uri="{FF2B5EF4-FFF2-40B4-BE49-F238E27FC236}">
+                <a16:creationId xmlns:a16="http://schemas.microsoft.com/office/drawing/2014/main" id="{54CD70F6-CA79-D71C-0362-0FDA1F9BC8BB}"/>
+              </a:ext>
+            </a:extLst>
+          </p:cNvPr>
+          <p:cNvPicPr>
+            <a:picLocks noChangeAspect="1"/>
+          </p:cNvPicPr>
+          <p:nvPr/>
+        </p:nvPicPr>
+        <p:blipFill>
+          <a:blip r:embed="rId2"/>
+          <a:stretch>
+            <a:fillRect/>
+          </a:stretch>
+        </p:blipFill>
+        <p:spPr>
+          <a:xfrm>
+            <a:off x="2195945" y="1919775"/>
+            <a:ext cx="7776186" cy="4212592"/>
+          </a:xfrm>
+          <a:prstGeom prst="rect">
+            <a:avLst/>
+          </a:prstGeom>
+        </p:spPr>
+      </p:pic>
       <p:sp>
         <p:nvSpPr>
           <p:cNvPr id="5" name="Title 1">
@@ -4180,10 +4463,10 @@
         </p:nvGrpSpPr>
         <p:grpSpPr>
           <a:xfrm>
-            <a:off x="857213" y="1925917"/>
-            <a:ext cx="9124987" cy="4216400"/>
-            <a:chOff x="857213" y="1925917"/>
-            <a:chExt cx="9124987" cy="4216400"/>
+            <a:off x="857213" y="2304276"/>
+            <a:ext cx="8732836" cy="3557548"/>
+            <a:chOff x="857213" y="2304276"/>
+            <a:chExt cx="8732836" cy="3557548"/>
           </a:xfrm>
         </p:grpSpPr>
         <p:grpSp>
@@ -4200,41 +4483,12 @@
           </p:nvGrpSpPr>
           <p:grpSpPr>
             <a:xfrm>
-              <a:off x="2209800" y="1925917"/>
-              <a:ext cx="7772400" cy="4216400"/>
-              <a:chOff x="2209800" y="1925917"/>
-              <a:chExt cx="7772400" cy="4216400"/>
+              <a:off x="2583363" y="2304276"/>
+              <a:ext cx="7006686" cy="3557548"/>
+              <a:chOff x="2583363" y="2304276"/>
+              <a:chExt cx="7006686" cy="3557548"/>
             </a:xfrm>
           </p:grpSpPr>
-          <p:pic>
-            <p:nvPicPr>
-              <p:cNvPr id="9" name="Picture 8">
-                <a:extLst>
-                  <a:ext uri="{FF2B5EF4-FFF2-40B4-BE49-F238E27FC236}">
-                    <a16:creationId xmlns:a16="http://schemas.microsoft.com/office/drawing/2014/main" id="{C4E1869D-2F1A-4157-76F9-9B076ACE918A}"/>
-                  </a:ext>
-                </a:extLst>
-              </p:cNvPr>
-              <p:cNvPicPr>
-                <a:picLocks noChangeAspect="1"/>
-              </p:cNvPicPr>
-              <p:nvPr/>
-            </p:nvPicPr>
-            <p:blipFill>
-              <a:blip r:embed="rId2"/>
-              <a:srcRect/>
-              <a:stretch/>
-            </p:blipFill>
-            <p:spPr>
-              <a:xfrm>
-                <a:off x="2209800" y="1925917"/>
-                <a:ext cx="7772400" cy="4216400"/>
-              </a:xfrm>
-              <a:prstGeom prst="rect">
-                <a:avLst/>
-              </a:prstGeom>
-            </p:spPr>
-          </p:pic>
           <p:sp>
             <p:nvSpPr>
               <p:cNvPr id="10" name="Rectangle 9">
@@ -4345,114 +4599,6 @@
           </p:sp>
           <p:sp>
             <p:nvSpPr>
-              <p:cNvPr id="12" name="Rectangle 11">
-                <a:extLst>
-                  <a:ext uri="{FF2B5EF4-FFF2-40B4-BE49-F238E27FC236}">
-                    <a16:creationId xmlns:a16="http://schemas.microsoft.com/office/drawing/2014/main" id="{A22F3F91-1600-65D0-9942-04EE818B883C}"/>
-                  </a:ext>
-                </a:extLst>
-              </p:cNvPr>
-              <p:cNvSpPr/>
-              <p:nvPr/>
-            </p:nvSpPr>
-            <p:spPr>
-              <a:xfrm>
-                <a:off x="9144000" y="2765502"/>
-                <a:ext cx="446048" cy="2635095"/>
-              </a:xfrm>
-              <a:prstGeom prst="rect">
-                <a:avLst/>
-              </a:prstGeom>
-              <a:solidFill>
-                <a:srgbClr val="7F7F7F">
-                  <a:alpha val="50196"/>
-                </a:srgbClr>
-              </a:solidFill>
-              <a:ln>
-                <a:noFill/>
-              </a:ln>
-            </p:spPr>
-            <p:style>
-              <a:lnRef idx="2">
-                <a:schemeClr val="accent1">
-                  <a:shade val="15000"/>
-                </a:schemeClr>
-              </a:lnRef>
-              <a:fillRef idx="1">
-                <a:schemeClr val="accent1"/>
-              </a:fillRef>
-              <a:effectRef idx="0">
-                <a:schemeClr val="accent1"/>
-              </a:effectRef>
-              <a:fontRef idx="minor">
-                <a:schemeClr val="lt1"/>
-              </a:fontRef>
-            </p:style>
-            <p:txBody>
-              <a:bodyPr rtlCol="0" anchor="ctr"/>
-              <a:lstStyle/>
-              <a:p>
-                <a:pPr algn="ctr"/>
-                <a:endParaRPr lang="en-US"/>
-              </a:p>
-            </p:txBody>
-          </p:sp>
-          <p:sp>
-            <p:nvSpPr>
-              <p:cNvPr id="13" name="Rectangle 12">
-                <a:extLst>
-                  <a:ext uri="{FF2B5EF4-FFF2-40B4-BE49-F238E27FC236}">
-                    <a16:creationId xmlns:a16="http://schemas.microsoft.com/office/drawing/2014/main" id="{835AF841-8971-5263-AEE5-01D0D2A2115E}"/>
-                  </a:ext>
-                </a:extLst>
-              </p:cNvPr>
-              <p:cNvSpPr/>
-              <p:nvPr/>
-            </p:nvSpPr>
-            <p:spPr>
-              <a:xfrm>
-                <a:off x="2583364" y="2765502"/>
-                <a:ext cx="446048" cy="2635095"/>
-              </a:xfrm>
-              <a:prstGeom prst="rect">
-                <a:avLst/>
-              </a:prstGeom>
-              <a:solidFill>
-                <a:srgbClr val="7F7F7F">
-                  <a:alpha val="50196"/>
-                </a:srgbClr>
-              </a:solidFill>
-              <a:ln>
-                <a:noFill/>
-              </a:ln>
-            </p:spPr>
-            <p:style>
-              <a:lnRef idx="2">
-                <a:schemeClr val="accent1">
-                  <a:shade val="15000"/>
-                </a:schemeClr>
-              </a:lnRef>
-              <a:fillRef idx="1">
-                <a:schemeClr val="accent1"/>
-              </a:fillRef>
-              <a:effectRef idx="0">
-                <a:schemeClr val="accent1"/>
-              </a:effectRef>
-              <a:fontRef idx="minor">
-                <a:schemeClr val="lt1"/>
-              </a:fontRef>
-            </p:style>
-            <p:txBody>
-              <a:bodyPr rtlCol="0" anchor="ctr"/>
-              <a:lstStyle/>
-              <a:p>
-                <a:pPr algn="ctr"/>
-                <a:endParaRPr lang="en-US"/>
-              </a:p>
-            </p:txBody>
-          </p:sp>
-          <p:sp>
-            <p:nvSpPr>
               <p:cNvPr id="15" name="Rectangle 14">
                 <a:extLst>
                   <a:ext uri="{FF2B5EF4-FFF2-40B4-BE49-F238E27FC236}">
@@ -4465,8 +4611,8 @@
             </p:nvSpPr>
             <p:spPr>
               <a:xfrm>
-                <a:off x="3029411" y="2719555"/>
-                <a:ext cx="6114587" cy="461226"/>
+                <a:off x="2583363" y="2719555"/>
+                <a:ext cx="7006622" cy="461226"/>
               </a:xfrm>
               <a:prstGeom prst="rect">
                 <a:avLst/>
@@ -4554,8 +4700,8 @@
           </p:nvSpPr>
           <p:spPr>
             <a:xfrm>
-              <a:off x="3029409" y="3215241"/>
-              <a:ext cx="6114587" cy="392307"/>
+              <a:off x="2583363" y="3215241"/>
+              <a:ext cx="7006622" cy="392307"/>
             </a:xfrm>
             <a:prstGeom prst="rect">
               <a:avLst/>
@@ -4606,8 +4752,8 @@
           </p:nvSpPr>
           <p:spPr>
             <a:xfrm>
-              <a:off x="3029405" y="3621823"/>
-              <a:ext cx="6114587" cy="461226"/>
+              <a:off x="2583357" y="3621823"/>
+              <a:ext cx="7006628" cy="461226"/>
             </a:xfrm>
             <a:prstGeom prst="rect">
               <a:avLst/>
@@ -4658,8 +4804,8 @@
           </p:nvSpPr>
           <p:spPr>
             <a:xfrm>
-              <a:off x="3029397" y="4108812"/>
-              <a:ext cx="6114587" cy="415278"/>
+              <a:off x="2583351" y="4108812"/>
+              <a:ext cx="7006634" cy="415278"/>
             </a:xfrm>
             <a:prstGeom prst="rect">
               <a:avLst/>
@@ -4710,8 +4856,8 @@
           </p:nvSpPr>
           <p:spPr>
             <a:xfrm>
-              <a:off x="3029381" y="4558552"/>
-              <a:ext cx="6114587" cy="403792"/>
+              <a:off x="2583333" y="4558552"/>
+              <a:ext cx="7006652" cy="403792"/>
             </a:xfrm>
             <a:prstGeom prst="rect">
               <a:avLst/>
@@ -4762,8 +4908,8 @@
           </p:nvSpPr>
           <p:spPr>
             <a:xfrm>
-              <a:off x="3029349" y="4996806"/>
-              <a:ext cx="6114587" cy="378082"/>
+              <a:off x="2583303" y="4996806"/>
+              <a:ext cx="7006682" cy="378082"/>
             </a:xfrm>
             <a:prstGeom prst="rect">
               <a:avLst/>
@@ -5017,6 +5163,36 @@
           <a:chExt cx="0" cy="0"/>
         </a:xfrm>
       </p:grpSpPr>
+      <p:pic>
+        <p:nvPicPr>
+          <p:cNvPr id="6" name="Picture 5">
+            <a:extLst>
+              <a:ext uri="{FF2B5EF4-FFF2-40B4-BE49-F238E27FC236}">
+                <a16:creationId xmlns:a16="http://schemas.microsoft.com/office/drawing/2014/main" id="{E005A370-21BB-43F8-553F-2A1CFB6A2590}"/>
+              </a:ext>
+            </a:extLst>
+          </p:cNvPr>
+          <p:cNvPicPr>
+            <a:picLocks noChangeAspect="1"/>
+          </p:cNvPicPr>
+          <p:nvPr/>
+        </p:nvPicPr>
+        <p:blipFill>
+          <a:blip r:embed="rId2"/>
+          <a:stretch>
+            <a:fillRect/>
+          </a:stretch>
+        </p:blipFill>
+        <p:spPr>
+          <a:xfrm>
+            <a:off x="2209800" y="1917430"/>
+            <a:ext cx="7772400" cy="4216940"/>
+          </a:xfrm>
+          <a:prstGeom prst="rect">
+            <a:avLst/>
+          </a:prstGeom>
+        </p:spPr>
+      </p:pic>
       <p:sp>
         <p:nvSpPr>
           <p:cNvPr id="5" name="Title 1">
@@ -5045,17 +5221,17 @@
           <a:p>
             <a:r>
               <a:rPr lang="en-US" dirty="0"/>
-              <a:t>CUT page</a:t>
+              <a:t>Title page</a:t>
             </a:r>
           </a:p>
         </p:txBody>
       </p:sp>
       <p:grpSp>
         <p:nvGrpSpPr>
-          <p:cNvPr id="4" name="Group 3">
-            <a:extLst>
-              <a:ext uri="{FF2B5EF4-FFF2-40B4-BE49-F238E27FC236}">
-                <a16:creationId xmlns:a16="http://schemas.microsoft.com/office/drawing/2014/main" id="{3A64EF66-8EB7-65A3-00D6-85F6342908A9}"/>
+          <p:cNvPr id="30" name="Group 29">
+            <a:extLst>
+              <a:ext uri="{FF2B5EF4-FFF2-40B4-BE49-F238E27FC236}">
+                <a16:creationId xmlns:a16="http://schemas.microsoft.com/office/drawing/2014/main" id="{D847C675-2494-CFFA-0C7C-9439AB90E1DD}"/>
               </a:ext>
             </a:extLst>
           </p:cNvPr>
@@ -5064,18 +5240,18 @@
         </p:nvGrpSpPr>
         <p:grpSpPr>
           <a:xfrm>
-            <a:off x="2209800" y="1737396"/>
-            <a:ext cx="7772400" cy="4736248"/>
-            <a:chOff x="2209800" y="1737396"/>
-            <a:chExt cx="7772400" cy="4736248"/>
+            <a:off x="4330388" y="3190323"/>
+            <a:ext cx="4401017" cy="1769955"/>
+            <a:chOff x="4330388" y="3190323"/>
+            <a:chExt cx="4401017" cy="1769955"/>
           </a:xfrm>
         </p:grpSpPr>
         <p:grpSp>
           <p:nvGrpSpPr>
-            <p:cNvPr id="30" name="Group 29">
+            <p:cNvPr id="26" name="Group 25">
               <a:extLst>
                 <a:ext uri="{FF2B5EF4-FFF2-40B4-BE49-F238E27FC236}">
-                  <a16:creationId xmlns:a16="http://schemas.microsoft.com/office/drawing/2014/main" id="{D847C675-2494-CFFA-0C7C-9439AB90E1DD}"/>
+                  <a16:creationId xmlns:a16="http://schemas.microsoft.com/office/drawing/2014/main" id="{F4B025FE-F67B-8EDB-EF19-EDA9B0CB01AB}"/>
                 </a:ext>
               </a:extLst>
             </p:cNvPr>
@@ -5084,10 +5260,445 @@
           </p:nvGrpSpPr>
           <p:grpSpPr>
             <a:xfrm>
-              <a:off x="2209800" y="1925647"/>
-              <a:ext cx="7772400" cy="4216940"/>
-              <a:chOff x="2209800" y="1925647"/>
-              <a:chExt cx="7772400" cy="4216940"/>
+              <a:off x="4330388" y="3190323"/>
+              <a:ext cx="4401017" cy="1769955"/>
+              <a:chOff x="4330388" y="3190323"/>
+              <a:chExt cx="4401017" cy="1769955"/>
+            </a:xfrm>
+          </p:grpSpPr>
+          <p:sp>
+            <p:nvSpPr>
+              <p:cNvPr id="15" name="Rectangle 14">
+                <a:extLst>
+                  <a:ext uri="{FF2B5EF4-FFF2-40B4-BE49-F238E27FC236}">
+                    <a16:creationId xmlns:a16="http://schemas.microsoft.com/office/drawing/2014/main" id="{699A5C98-8BEB-BF15-CFB0-584B7604A86B}"/>
+                  </a:ext>
+                </a:extLst>
+              </p:cNvPr>
+              <p:cNvSpPr/>
+              <p:nvPr/>
+            </p:nvSpPr>
+            <p:spPr>
+              <a:xfrm>
+                <a:off x="4330388" y="3625849"/>
+                <a:ext cx="464636" cy="457200"/>
+              </a:xfrm>
+              <a:prstGeom prst="rect">
+                <a:avLst/>
+              </a:prstGeom>
+              <a:noFill/>
+              <a:ln w="38100">
+                <a:solidFill>
+                  <a:schemeClr val="accent3"/>
+                </a:solidFill>
+              </a:ln>
+            </p:spPr>
+            <p:style>
+              <a:lnRef idx="2">
+                <a:schemeClr val="accent1">
+                  <a:shade val="15000"/>
+                </a:schemeClr>
+              </a:lnRef>
+              <a:fillRef idx="1">
+                <a:schemeClr val="accent1"/>
+              </a:fillRef>
+              <a:effectRef idx="0">
+                <a:schemeClr val="accent1"/>
+              </a:effectRef>
+              <a:fontRef idx="minor">
+                <a:schemeClr val="lt1"/>
+              </a:fontRef>
+            </p:style>
+            <p:txBody>
+              <a:bodyPr rtlCol="0" anchor="ctr"/>
+              <a:lstStyle/>
+              <a:p>
+                <a:pPr algn="ctr"/>
+                <a:endParaRPr lang="en-US"/>
+              </a:p>
+            </p:txBody>
+          </p:sp>
+          <p:sp>
+            <p:nvSpPr>
+              <p:cNvPr id="17" name="Rectangle 16">
+                <a:extLst>
+                  <a:ext uri="{FF2B5EF4-FFF2-40B4-BE49-F238E27FC236}">
+                    <a16:creationId xmlns:a16="http://schemas.microsoft.com/office/drawing/2014/main" id="{DA3E4A49-B3F5-C81F-2587-06F7913E3020}"/>
+                  </a:ext>
+                </a:extLst>
+              </p:cNvPr>
+              <p:cNvSpPr/>
+              <p:nvPr/>
+            </p:nvSpPr>
+            <p:spPr>
+              <a:xfrm>
+                <a:off x="6958359" y="4503078"/>
+                <a:ext cx="464636" cy="457200"/>
+              </a:xfrm>
+              <a:prstGeom prst="rect">
+                <a:avLst/>
+              </a:prstGeom>
+              <a:noFill/>
+              <a:ln w="38100">
+                <a:solidFill>
+                  <a:schemeClr val="accent3"/>
+                </a:solidFill>
+              </a:ln>
+            </p:spPr>
+            <p:style>
+              <a:lnRef idx="2">
+                <a:schemeClr val="accent1">
+                  <a:shade val="15000"/>
+                </a:schemeClr>
+              </a:lnRef>
+              <a:fillRef idx="1">
+                <a:schemeClr val="accent1"/>
+              </a:fillRef>
+              <a:effectRef idx="0">
+                <a:schemeClr val="accent1"/>
+              </a:effectRef>
+              <a:fontRef idx="minor">
+                <a:schemeClr val="lt1"/>
+              </a:fontRef>
+            </p:style>
+            <p:txBody>
+              <a:bodyPr rtlCol="0" anchor="ctr"/>
+              <a:lstStyle/>
+              <a:p>
+                <a:pPr algn="ctr"/>
+                <a:endParaRPr lang="en-US"/>
+              </a:p>
+            </p:txBody>
+          </p:sp>
+          <p:cxnSp>
+            <p:nvCxnSpPr>
+              <p:cNvPr id="19" name="Straight Arrow Connector 18">
+                <a:extLst>
+                  <a:ext uri="{FF2B5EF4-FFF2-40B4-BE49-F238E27FC236}">
+                    <a16:creationId xmlns:a16="http://schemas.microsoft.com/office/drawing/2014/main" id="{B281E88A-417F-C3C8-7FD4-D577FBB87472}"/>
+                  </a:ext>
+                </a:extLst>
+              </p:cNvPr>
+              <p:cNvCxnSpPr>
+                <a:stCxn id="15" idx="3"/>
+              </p:cNvCxnSpPr>
+              <p:nvPr/>
+            </p:nvCxnSpPr>
+            <p:spPr>
+              <a:xfrm>
+                <a:off x="4795024" y="3854449"/>
+                <a:ext cx="669074" cy="0"/>
+              </a:xfrm>
+              <a:prstGeom prst="straightConnector1">
+                <a:avLst/>
+              </a:prstGeom>
+              <a:ln w="38100">
+                <a:solidFill>
+                  <a:schemeClr val="accent3"/>
+                </a:solidFill>
+                <a:tailEnd type="triangle"/>
+              </a:ln>
+            </p:spPr>
+            <p:style>
+              <a:lnRef idx="2">
+                <a:schemeClr val="accent1"/>
+              </a:lnRef>
+              <a:fillRef idx="0">
+                <a:schemeClr val="accent1"/>
+              </a:fillRef>
+              <a:effectRef idx="1">
+                <a:schemeClr val="accent1"/>
+              </a:effectRef>
+              <a:fontRef idx="minor">
+                <a:schemeClr val="tx1"/>
+              </a:fontRef>
+            </p:style>
+          </p:cxnSp>
+          <p:cxnSp>
+            <p:nvCxnSpPr>
+              <p:cNvPr id="20" name="Straight Arrow Connector 19">
+                <a:extLst>
+                  <a:ext uri="{FF2B5EF4-FFF2-40B4-BE49-F238E27FC236}">
+                    <a16:creationId xmlns:a16="http://schemas.microsoft.com/office/drawing/2014/main" id="{0ED4CAE8-1848-2DC8-E515-7AAEA148A41C}"/>
+                  </a:ext>
+                </a:extLst>
+              </p:cNvPr>
+              <p:cNvCxnSpPr>
+                <a:cxnSpLocks/>
+                <a:stCxn id="17" idx="1"/>
+              </p:cNvCxnSpPr>
+              <p:nvPr/>
+            </p:nvCxnSpPr>
+            <p:spPr>
+              <a:xfrm flipH="1">
+                <a:off x="6287427" y="4731678"/>
+                <a:ext cx="670932" cy="0"/>
+              </a:xfrm>
+              <a:prstGeom prst="straightConnector1">
+                <a:avLst/>
+              </a:prstGeom>
+              <a:ln w="38100">
+                <a:solidFill>
+                  <a:schemeClr val="accent3"/>
+                </a:solidFill>
+                <a:tailEnd type="triangle"/>
+              </a:ln>
+            </p:spPr>
+            <p:style>
+              <a:lnRef idx="2">
+                <a:schemeClr val="accent1"/>
+              </a:lnRef>
+              <a:fillRef idx="0">
+                <a:schemeClr val="accent1"/>
+              </a:fillRef>
+              <a:effectRef idx="1">
+                <a:schemeClr val="accent1"/>
+              </a:effectRef>
+              <a:fontRef idx="minor">
+                <a:schemeClr val="tx1"/>
+              </a:fontRef>
+            </p:style>
+          </p:cxnSp>
+          <p:sp>
+            <p:nvSpPr>
+              <p:cNvPr id="25" name="Rectangle 24">
+                <a:extLst>
+                  <a:ext uri="{FF2B5EF4-FFF2-40B4-BE49-F238E27FC236}">
+                    <a16:creationId xmlns:a16="http://schemas.microsoft.com/office/drawing/2014/main" id="{7C84101F-7E26-6DDB-894B-E1122235FD59}"/>
+                  </a:ext>
+                </a:extLst>
+              </p:cNvPr>
+              <p:cNvSpPr/>
+              <p:nvPr/>
+            </p:nvSpPr>
+            <p:spPr>
+              <a:xfrm>
+                <a:off x="6527177" y="3190323"/>
+                <a:ext cx="2204228" cy="457200"/>
+              </a:xfrm>
+              <a:prstGeom prst="rect">
+                <a:avLst/>
+              </a:prstGeom>
+              <a:noFill/>
+              <a:ln w="38100">
+                <a:solidFill>
+                  <a:schemeClr val="accent3"/>
+                </a:solidFill>
+              </a:ln>
+            </p:spPr>
+            <p:style>
+              <a:lnRef idx="2">
+                <a:schemeClr val="accent1">
+                  <a:shade val="15000"/>
+                </a:schemeClr>
+              </a:lnRef>
+              <a:fillRef idx="1">
+                <a:schemeClr val="accent1"/>
+              </a:fillRef>
+              <a:effectRef idx="0">
+                <a:schemeClr val="accent1"/>
+              </a:effectRef>
+              <a:fontRef idx="minor">
+                <a:schemeClr val="lt1"/>
+              </a:fontRef>
+            </p:style>
+            <p:txBody>
+              <a:bodyPr rtlCol="0" anchor="ctr"/>
+              <a:lstStyle/>
+              <a:p>
+                <a:pPr algn="ctr"/>
+                <a:endParaRPr lang="en-US"/>
+              </a:p>
+            </p:txBody>
+          </p:sp>
+        </p:grpSp>
+        <p:cxnSp>
+          <p:nvCxnSpPr>
+            <p:cNvPr id="28" name="Elbow Connector 27">
+              <a:extLst>
+                <a:ext uri="{FF2B5EF4-FFF2-40B4-BE49-F238E27FC236}">
+                  <a16:creationId xmlns:a16="http://schemas.microsoft.com/office/drawing/2014/main" id="{5ECA5C97-FD3E-32AA-DCE7-B6A6F44F7A98}"/>
+                </a:ext>
+              </a:extLst>
+            </p:cNvPr>
+            <p:cNvCxnSpPr>
+              <a:stCxn id="25" idx="3"/>
+              <a:endCxn id="25" idx="1"/>
+            </p:cNvCxnSpPr>
+            <p:nvPr/>
+          </p:nvCxnSpPr>
+          <p:spPr>
+            <a:xfrm flipH="1">
+              <a:off x="6527177" y="3418923"/>
+              <a:ext cx="2204228" cy="12700"/>
+            </a:xfrm>
+            <a:prstGeom prst="bentConnector5">
+              <a:avLst>
+                <a:gd name="adj1" fmla="val -10371"/>
+                <a:gd name="adj2" fmla="val -3336583"/>
+                <a:gd name="adj3" fmla="val 110371"/>
+              </a:avLst>
+            </a:prstGeom>
+            <a:ln w="38100">
+              <a:solidFill>
+                <a:schemeClr val="accent3"/>
+              </a:solidFill>
+              <a:tailEnd type="triangle"/>
+            </a:ln>
+          </p:spPr>
+          <p:style>
+            <a:lnRef idx="2">
+              <a:schemeClr val="accent1"/>
+            </a:lnRef>
+            <a:fillRef idx="0">
+              <a:schemeClr val="accent1"/>
+            </a:fillRef>
+            <a:effectRef idx="1">
+              <a:schemeClr val="accent1"/>
+            </a:effectRef>
+            <a:fontRef idx="minor">
+              <a:schemeClr val="tx1"/>
+            </a:fontRef>
+          </p:style>
+        </p:cxnSp>
+      </p:grpSp>
+    </p:spTree>
+    <p:extLst>
+      <p:ext uri="{BB962C8B-B14F-4D97-AF65-F5344CB8AC3E}">
+        <p14:creationId xmlns:p14="http://schemas.microsoft.com/office/powerpoint/2010/main" val="3361061764"/>
+      </p:ext>
+    </p:extLst>
+  </p:cSld>
+  <p:clrMapOvr>
+    <a:masterClrMapping/>
+  </p:clrMapOvr>
+</p:sld>
+</file>
+
+<file path=ppt/slides/slide4.xml><?xml version="1.0" encoding="utf-8"?>
+<p:sld xmlns:a="http://schemas.openxmlformats.org/drawingml/2006/main" xmlns:r="http://schemas.openxmlformats.org/officeDocument/2006/relationships" xmlns:p="http://schemas.openxmlformats.org/presentationml/2006/main">
+  <p:cSld>
+    <p:spTree>
+      <p:nvGrpSpPr>
+        <p:cNvPr id="1" name="">
+          <a:extLst>
+            <a:ext uri="{FF2B5EF4-FFF2-40B4-BE49-F238E27FC236}">
+              <a16:creationId xmlns:a16="http://schemas.microsoft.com/office/drawing/2014/main" id="{3506BEC5-51A7-EFB9-4782-1A56CFF96549}"/>
+            </a:ext>
+          </a:extLst>
+        </p:cNvPr>
+        <p:cNvGrpSpPr/>
+        <p:nvPr/>
+      </p:nvGrpSpPr>
+      <p:grpSpPr>
+        <a:xfrm>
+          <a:off x="0" y="0"/>
+          <a:ext cx="0" cy="0"/>
+          <a:chOff x="0" y="0"/>
+          <a:chExt cx="0" cy="0"/>
+        </a:xfrm>
+      </p:grpSpPr>
+      <p:pic>
+        <p:nvPicPr>
+          <p:cNvPr id="6" name="Picture 5">
+            <a:extLst>
+              <a:ext uri="{FF2B5EF4-FFF2-40B4-BE49-F238E27FC236}">
+                <a16:creationId xmlns:a16="http://schemas.microsoft.com/office/drawing/2014/main" id="{0825DAE8-41D6-BF7D-888F-E1629DF46FE9}"/>
+              </a:ext>
+            </a:extLst>
+          </p:cNvPr>
+          <p:cNvPicPr>
+            <a:picLocks noChangeAspect="1"/>
+          </p:cNvPicPr>
+          <p:nvPr/>
+        </p:nvPicPr>
+        <p:blipFill>
+          <a:blip r:embed="rId2"/>
+          <a:stretch>
+            <a:fillRect/>
+          </a:stretch>
+        </p:blipFill>
+        <p:spPr>
+          <a:xfrm>
+            <a:off x="2209800" y="1917430"/>
+            <a:ext cx="7772400" cy="4216940"/>
+          </a:xfrm>
+          <a:prstGeom prst="rect">
+            <a:avLst/>
+          </a:prstGeom>
+        </p:spPr>
+      </p:pic>
+      <p:sp>
+        <p:nvSpPr>
+          <p:cNvPr id="5" name="Title 1">
+            <a:extLst>
+              <a:ext uri="{FF2B5EF4-FFF2-40B4-BE49-F238E27FC236}">
+                <a16:creationId xmlns:a16="http://schemas.microsoft.com/office/drawing/2014/main" id="{A13E4A06-279D-F4A8-3574-58391AAE9F51}"/>
+              </a:ext>
+            </a:extLst>
+          </p:cNvPr>
+          <p:cNvSpPr>
+            <a:spLocks noGrp="1"/>
+          </p:cNvSpPr>
+          <p:nvPr>
+            <p:ph type="title"/>
+          </p:nvPr>
+        </p:nvSpPr>
+        <p:spPr>
+          <a:xfrm>
+            <a:off x="838200" y="365125"/>
+            <a:ext cx="10515600" cy="1325563"/>
+          </a:xfrm>
+        </p:spPr>
+        <p:txBody>
+          <a:bodyPr/>
+          <a:lstStyle/>
+          <a:p>
+            <a:r>
+              <a:rPr lang="en-US" dirty="0"/>
+              <a:t>CUT page</a:t>
+            </a:r>
+          </a:p>
+        </p:txBody>
+      </p:sp>
+      <p:grpSp>
+        <p:nvGrpSpPr>
+          <p:cNvPr id="4" name="Group 3">
+            <a:extLst>
+              <a:ext uri="{FF2B5EF4-FFF2-40B4-BE49-F238E27FC236}">
+                <a16:creationId xmlns:a16="http://schemas.microsoft.com/office/drawing/2014/main" id="{5DB63D87-5A63-79EB-6877-1A9B411B4419}"/>
+              </a:ext>
+            </a:extLst>
+          </p:cNvPr>
+          <p:cNvGrpSpPr/>
+          <p:nvPr/>
+        </p:nvGrpSpPr>
+        <p:grpSpPr>
+          <a:xfrm>
+            <a:off x="2281895" y="1737396"/>
+            <a:ext cx="7308154" cy="4736248"/>
+            <a:chOff x="2281895" y="1737396"/>
+            <a:chExt cx="7308154" cy="4736248"/>
+          </a:xfrm>
+        </p:grpSpPr>
+        <p:grpSp>
+          <p:nvGrpSpPr>
+            <p:cNvPr id="30" name="Group 29">
+              <a:extLst>
+                <a:ext uri="{FF2B5EF4-FFF2-40B4-BE49-F238E27FC236}">
+                  <a16:creationId xmlns:a16="http://schemas.microsoft.com/office/drawing/2014/main" id="{615D8E6B-E452-F587-3439-0F670969302F}"/>
+                </a:ext>
+              </a:extLst>
+            </p:cNvPr>
+            <p:cNvGrpSpPr/>
+            <p:nvPr/>
+          </p:nvGrpSpPr>
+          <p:grpSpPr>
+            <a:xfrm>
+              <a:off x="2572212" y="2301943"/>
+              <a:ext cx="7017837" cy="3559881"/>
+              <a:chOff x="2572212" y="2301943"/>
+              <a:chExt cx="7017837" cy="3559881"/>
             </a:xfrm>
           </p:grpSpPr>
           <p:grpSp>
@@ -5095,7 +5706,7 @@
               <p:cNvPr id="26" name="Group 25">
                 <a:extLst>
                   <a:ext uri="{FF2B5EF4-FFF2-40B4-BE49-F238E27FC236}">
-                    <a16:creationId xmlns:a16="http://schemas.microsoft.com/office/drawing/2014/main" id="{F4B025FE-F67B-8EDB-EF19-EDA9B0CB01AB}"/>
+                    <a16:creationId xmlns:a16="http://schemas.microsoft.com/office/drawing/2014/main" id="{F396101E-4239-726C-9E1A-E225AEEBF0FF}"/>
                   </a:ext>
                 </a:extLst>
               </p:cNvPr>
@@ -5104,48 +5715,18 @@
             </p:nvGrpSpPr>
             <p:grpSpPr>
               <a:xfrm>
-                <a:off x="2209800" y="1925647"/>
-                <a:ext cx="7772400" cy="4216940"/>
-                <a:chOff x="2209800" y="1925647"/>
-                <a:chExt cx="7772400" cy="4216940"/>
+                <a:off x="2572212" y="2301943"/>
+                <a:ext cx="7017837" cy="3559881"/>
+                <a:chOff x="2572212" y="2301943"/>
+                <a:chExt cx="7017837" cy="3559881"/>
               </a:xfrm>
             </p:grpSpPr>
-            <p:pic>
-              <p:nvPicPr>
-                <p:cNvPr id="9" name="Picture 8" descr="A grid of squares with yellow and white squares&#10;&#10;AI-generated content may be incorrect.">
-                  <a:extLst>
-                    <a:ext uri="{FF2B5EF4-FFF2-40B4-BE49-F238E27FC236}">
-                      <a16:creationId xmlns:a16="http://schemas.microsoft.com/office/drawing/2014/main" id="{91FA7AEE-0AD2-955E-65C3-2E582CC23B9F}"/>
-                    </a:ext>
-                  </a:extLst>
-                </p:cNvPr>
-                <p:cNvPicPr>
-                  <a:picLocks noChangeAspect="1"/>
-                </p:cNvPicPr>
-                <p:nvPr/>
-              </p:nvPicPr>
-              <p:blipFill>
-                <a:blip r:embed="rId2"/>
-                <a:stretch>
-                  <a:fillRect/>
-                </a:stretch>
-              </p:blipFill>
-              <p:spPr>
-                <a:xfrm>
-                  <a:off x="2209800" y="1925647"/>
-                  <a:ext cx="7772400" cy="4216940"/>
-                </a:xfrm>
-                <a:prstGeom prst="rect">
-                  <a:avLst/>
-                </a:prstGeom>
-              </p:spPr>
-            </p:pic>
             <p:sp>
               <p:nvSpPr>
                 <p:cNvPr id="10" name="Rectangle 9">
                   <a:extLst>
                     <a:ext uri="{FF2B5EF4-FFF2-40B4-BE49-F238E27FC236}">
-                      <a16:creationId xmlns:a16="http://schemas.microsoft.com/office/drawing/2014/main" id="{4D007FB5-CF4D-C7A6-4E90-B879EC1305D1}"/>
+                      <a16:creationId xmlns:a16="http://schemas.microsoft.com/office/drawing/2014/main" id="{709115A5-129E-A1C8-D9B9-CFE3193928DF}"/>
                     </a:ext>
                   </a:extLst>
                 </p:cNvPr>
@@ -5199,7 +5780,7 @@
                 <p:cNvPr id="11" name="Rectangle 10">
                   <a:extLst>
                     <a:ext uri="{FF2B5EF4-FFF2-40B4-BE49-F238E27FC236}">
-                      <a16:creationId xmlns:a16="http://schemas.microsoft.com/office/drawing/2014/main" id="{67DE9466-DC79-C0CD-6038-18DD873FBCF2}"/>
+                      <a16:creationId xmlns:a16="http://schemas.microsoft.com/office/drawing/2014/main" id="{FE547CC8-0A19-17D8-B22E-D32F921DD35D}"/>
                     </a:ext>
                   </a:extLst>
                 </p:cNvPr>
@@ -5250,118 +5831,10 @@
             </p:sp>
             <p:sp>
               <p:nvSpPr>
-                <p:cNvPr id="12" name="Rectangle 11">
-                  <a:extLst>
-                    <a:ext uri="{FF2B5EF4-FFF2-40B4-BE49-F238E27FC236}">
-                      <a16:creationId xmlns:a16="http://schemas.microsoft.com/office/drawing/2014/main" id="{0B25D718-4660-17D6-5027-C957ED6FDC3C}"/>
-                    </a:ext>
-                  </a:extLst>
-                </p:cNvPr>
-                <p:cNvSpPr/>
-                <p:nvPr/>
-              </p:nvSpPr>
-              <p:spPr>
-                <a:xfrm>
-                  <a:off x="9144000" y="2765502"/>
-                  <a:ext cx="446048" cy="2635095"/>
-                </a:xfrm>
-                <a:prstGeom prst="rect">
-                  <a:avLst/>
-                </a:prstGeom>
-                <a:solidFill>
-                  <a:srgbClr val="7F7F7F">
-                    <a:alpha val="50196"/>
-                  </a:srgbClr>
-                </a:solidFill>
-                <a:ln>
-                  <a:noFill/>
-                </a:ln>
-              </p:spPr>
-              <p:style>
-                <a:lnRef idx="2">
-                  <a:schemeClr val="accent1">
-                    <a:shade val="15000"/>
-                  </a:schemeClr>
-                </a:lnRef>
-                <a:fillRef idx="1">
-                  <a:schemeClr val="accent1"/>
-                </a:fillRef>
-                <a:effectRef idx="0">
-                  <a:schemeClr val="accent1"/>
-                </a:effectRef>
-                <a:fontRef idx="minor">
-                  <a:schemeClr val="lt1"/>
-                </a:fontRef>
-              </p:style>
-              <p:txBody>
-                <a:bodyPr rtlCol="0" anchor="ctr"/>
-                <a:lstStyle/>
-                <a:p>
-                  <a:pPr algn="ctr"/>
-                  <a:endParaRPr lang="en-US"/>
-                </a:p>
-              </p:txBody>
-            </p:sp>
-            <p:sp>
-              <p:nvSpPr>
-                <p:cNvPr id="13" name="Rectangle 12">
-                  <a:extLst>
-                    <a:ext uri="{FF2B5EF4-FFF2-40B4-BE49-F238E27FC236}">
-                      <a16:creationId xmlns:a16="http://schemas.microsoft.com/office/drawing/2014/main" id="{29B8990E-91B0-72C2-83E8-472699B82011}"/>
-                    </a:ext>
-                  </a:extLst>
-                </p:cNvPr>
-                <p:cNvSpPr/>
-                <p:nvPr/>
-              </p:nvSpPr>
-              <p:spPr>
-                <a:xfrm>
-                  <a:off x="2583364" y="2765502"/>
-                  <a:ext cx="446048" cy="2635095"/>
-                </a:xfrm>
-                <a:prstGeom prst="rect">
-                  <a:avLst/>
-                </a:prstGeom>
-                <a:solidFill>
-                  <a:srgbClr val="7F7F7F">
-                    <a:alpha val="50196"/>
-                  </a:srgbClr>
-                </a:solidFill>
-                <a:ln>
-                  <a:noFill/>
-                </a:ln>
-              </p:spPr>
-              <p:style>
-                <a:lnRef idx="2">
-                  <a:schemeClr val="accent1">
-                    <a:shade val="15000"/>
-                  </a:schemeClr>
-                </a:lnRef>
-                <a:fillRef idx="1">
-                  <a:schemeClr val="accent1"/>
-                </a:fillRef>
-                <a:effectRef idx="0">
-                  <a:schemeClr val="accent1"/>
-                </a:effectRef>
-                <a:fontRef idx="minor">
-                  <a:schemeClr val="lt1"/>
-                </a:fontRef>
-              </p:style>
-              <p:txBody>
-                <a:bodyPr rtlCol="0" anchor="ctr"/>
-                <a:lstStyle/>
-                <a:p>
-                  <a:pPr algn="ctr"/>
-                  <a:endParaRPr lang="en-US"/>
-                </a:p>
-              </p:txBody>
-            </p:sp>
-            <p:sp>
-              <p:nvSpPr>
                 <p:cNvPr id="14" name="Rectangle 13">
                   <a:extLst>
                     <a:ext uri="{FF2B5EF4-FFF2-40B4-BE49-F238E27FC236}">
-                      <a16:creationId xmlns:a16="http://schemas.microsoft.com/office/drawing/2014/main" id="{C1877C80-C946-603F-81B8-AD9FB87C79A8}"/>
+                      <a16:creationId xmlns:a16="http://schemas.microsoft.com/office/drawing/2014/main" id="{078DDC22-F718-B303-B714-A1EA6F79306F}"/>
                     </a:ext>
                   </a:extLst>
                 </p:cNvPr>
@@ -5413,7 +5886,7 @@
                 <p:cNvPr id="15" name="Rectangle 14">
                   <a:extLst>
                     <a:ext uri="{FF2B5EF4-FFF2-40B4-BE49-F238E27FC236}">
-                      <a16:creationId xmlns:a16="http://schemas.microsoft.com/office/drawing/2014/main" id="{699A5C98-8BEB-BF15-CFB0-584B7604A86B}"/>
+                      <a16:creationId xmlns:a16="http://schemas.microsoft.com/office/drawing/2014/main" id="{4896EAA6-E192-0D43-7BB4-4D023200912E}"/>
                     </a:ext>
                   </a:extLst>
                 </p:cNvPr>
@@ -5465,7 +5938,7 @@
                 <p:cNvPr id="17" name="Rectangle 16">
                   <a:extLst>
                     <a:ext uri="{FF2B5EF4-FFF2-40B4-BE49-F238E27FC236}">
-                      <a16:creationId xmlns:a16="http://schemas.microsoft.com/office/drawing/2014/main" id="{DA3E4A49-B3F5-C81F-2587-06F7913E3020}"/>
+                      <a16:creationId xmlns:a16="http://schemas.microsoft.com/office/drawing/2014/main" id="{46D2C5AF-5AA5-B0D5-FE85-014366FB7476}"/>
                     </a:ext>
                   </a:extLst>
                 </p:cNvPr>
@@ -5517,7 +5990,7 @@
                 <p:cNvPr id="19" name="Straight Arrow Connector 18">
                   <a:extLst>
                     <a:ext uri="{FF2B5EF4-FFF2-40B4-BE49-F238E27FC236}">
-                      <a16:creationId xmlns:a16="http://schemas.microsoft.com/office/drawing/2014/main" id="{B281E88A-417F-C3C8-7FD4-D577FBB87472}"/>
+                      <a16:creationId xmlns:a16="http://schemas.microsoft.com/office/drawing/2014/main" id="{BCC619A8-ECBF-34BD-DFCF-DCE156F6869D}"/>
                     </a:ext>
                   </a:extLst>
                 </p:cNvPr>
@@ -5561,7 +6034,7 @@
                 <p:cNvPr id="20" name="Straight Arrow Connector 19">
                   <a:extLst>
                     <a:ext uri="{FF2B5EF4-FFF2-40B4-BE49-F238E27FC236}">
-                      <a16:creationId xmlns:a16="http://schemas.microsoft.com/office/drawing/2014/main" id="{0ED4CAE8-1848-2DC8-E515-7AAEA148A41C}"/>
+                      <a16:creationId xmlns:a16="http://schemas.microsoft.com/office/drawing/2014/main" id="{1461200D-FDC1-1075-2BC7-0174D85298D7}"/>
                     </a:ext>
                   </a:extLst>
                 </p:cNvPr>
@@ -5606,7 +6079,7 @@
                 <p:cNvPr id="25" name="Rectangle 24">
                   <a:extLst>
                     <a:ext uri="{FF2B5EF4-FFF2-40B4-BE49-F238E27FC236}">
-                      <a16:creationId xmlns:a16="http://schemas.microsoft.com/office/drawing/2014/main" id="{7C84101F-7E26-6DDB-894B-E1122235FD59}"/>
+                      <a16:creationId xmlns:a16="http://schemas.microsoft.com/office/drawing/2014/main" id="{13BB85E5-5321-84F9-8AD0-55F41EC539DC}"/>
                     </a:ext>
                   </a:extLst>
                 </p:cNvPr>
@@ -5659,7 +6132,7 @@
               <p:cNvPr id="28" name="Elbow Connector 27">
                 <a:extLst>
                   <a:ext uri="{FF2B5EF4-FFF2-40B4-BE49-F238E27FC236}">
-                    <a16:creationId xmlns:a16="http://schemas.microsoft.com/office/drawing/2014/main" id="{5ECA5C97-FD3E-32AA-DCE7-B6A6F44F7A98}"/>
+                    <a16:creationId xmlns:a16="http://schemas.microsoft.com/office/drawing/2014/main" id="{9E6A5C35-A7D7-3734-AA29-A73FFB8ED668}"/>
                   </a:ext>
                 </a:extLst>
               </p:cNvPr>
@@ -5709,7 +6182,7 @@
             <p:cNvPr id="31" name="TextBox 30">
               <a:extLst>
                 <a:ext uri="{FF2B5EF4-FFF2-40B4-BE49-F238E27FC236}">
-                  <a16:creationId xmlns:a16="http://schemas.microsoft.com/office/drawing/2014/main" id="{5C4A4920-213F-B11C-D4AE-3C7FDE1DD2A8}"/>
+                  <a16:creationId xmlns:a16="http://schemas.microsoft.com/office/drawing/2014/main" id="{BA55EF82-EA99-213F-9E04-FE0171298FF9}"/>
                 </a:ext>
               </a:extLst>
             </p:cNvPr>
@@ -5744,7 +6217,7 @@
             <p:cNvPr id="2" name="TextBox 1">
               <a:extLst>
                 <a:ext uri="{FF2B5EF4-FFF2-40B4-BE49-F238E27FC236}">
-                  <a16:creationId xmlns:a16="http://schemas.microsoft.com/office/drawing/2014/main" id="{3BD79F66-7498-F538-BB75-051F91AECD82}"/>
+                  <a16:creationId xmlns:a16="http://schemas.microsoft.com/office/drawing/2014/main" id="{80E74414-F799-E60E-443A-78E8A7660FF5}"/>
                 </a:ext>
               </a:extLst>
             </p:cNvPr>
@@ -5779,7 +6252,7 @@
             <p:cNvPr id="3" name="TextBox 2">
               <a:extLst>
                 <a:ext uri="{FF2B5EF4-FFF2-40B4-BE49-F238E27FC236}">
-                  <a16:creationId xmlns:a16="http://schemas.microsoft.com/office/drawing/2014/main" id="{0809ECF9-541B-4E26-D407-79F20DA03490}"/>
+                  <a16:creationId xmlns:a16="http://schemas.microsoft.com/office/drawing/2014/main" id="{EA013142-4295-2DCC-060F-CF6746D5B09A}"/>
                 </a:ext>
               </a:extLst>
             </p:cNvPr>
@@ -5813,7 +6286,7 @@
     </p:spTree>
     <p:extLst>
       <p:ext uri="{BB962C8B-B14F-4D97-AF65-F5344CB8AC3E}">
-        <p14:creationId xmlns:p14="http://schemas.microsoft.com/office/powerpoint/2010/main" val="3361061764"/>
+        <p14:creationId xmlns:p14="http://schemas.microsoft.com/office/powerpoint/2010/main" val="1184266656"/>
       </p:ext>
     </p:extLst>
   </p:cSld>
@@ -5823,7 +6296,7 @@
 </p:sld>
 </file>
 
-<file path=ppt/slides/slide4.xml><?xml version="1.0" encoding="utf-8"?>
+<file path=ppt/slides/slide5.xml><?xml version="1.0" encoding="utf-8"?>
 <p:sld xmlns:a="http://schemas.openxmlformats.org/drawingml/2006/main" xmlns:r="http://schemas.openxmlformats.org/officeDocument/2006/relationships" xmlns:p="http://schemas.openxmlformats.org/presentationml/2006/main">
   <p:cSld>
     <p:spTree>
@@ -5840,6 +6313,36 @@
           <a:chExt cx="0" cy="0"/>
         </a:xfrm>
       </p:grpSpPr>
+      <p:pic>
+        <p:nvPicPr>
+          <p:cNvPr id="3" name="Picture 2">
+            <a:extLst>
+              <a:ext uri="{FF2B5EF4-FFF2-40B4-BE49-F238E27FC236}">
+                <a16:creationId xmlns:a16="http://schemas.microsoft.com/office/drawing/2014/main" id="{6AF67838-40B7-0614-6D2F-49EAFD1314D0}"/>
+              </a:ext>
+            </a:extLst>
+          </p:cNvPr>
+          <p:cNvPicPr>
+            <a:picLocks noChangeAspect="1"/>
+          </p:cNvPicPr>
+          <p:nvPr/>
+        </p:nvPicPr>
+        <p:blipFill>
+          <a:blip r:embed="rId2"/>
+          <a:stretch>
+            <a:fillRect/>
+          </a:stretch>
+        </p:blipFill>
+        <p:spPr>
+          <a:xfrm>
+            <a:off x="2393950" y="1669780"/>
+            <a:ext cx="7772400" cy="4216940"/>
+          </a:xfrm>
+          <a:prstGeom prst="rect">
+            <a:avLst/>
+          </a:prstGeom>
+        </p:spPr>
+      </p:pic>
       <p:sp>
         <p:nvSpPr>
           <p:cNvPr id="2" name="Title 1">
@@ -5882,10 +6385,10 @@
         </p:nvGrpSpPr>
         <p:grpSpPr>
           <a:xfrm>
-            <a:off x="2412243" y="1512381"/>
-            <a:ext cx="7772400" cy="4384906"/>
-            <a:chOff x="2412243" y="1512381"/>
-            <a:chExt cx="7772400" cy="4384906"/>
+            <a:off x="2460315" y="1512381"/>
+            <a:ext cx="7308154" cy="4093594"/>
+            <a:chOff x="2460315" y="1512381"/>
+            <a:chExt cx="7308154" cy="4093594"/>
           </a:xfrm>
         </p:grpSpPr>
         <p:grpSp>
@@ -5902,42 +6405,12 @@
           </p:nvGrpSpPr>
           <p:grpSpPr>
             <a:xfrm>
-              <a:off x="2412243" y="1685759"/>
-              <a:ext cx="7772400" cy="4211528"/>
-              <a:chOff x="2412243" y="1685759"/>
-              <a:chExt cx="7772400" cy="4211528"/>
+              <a:off x="2761204" y="2048428"/>
+              <a:ext cx="7007265" cy="3557547"/>
+              <a:chOff x="2761204" y="2048428"/>
+              <a:chExt cx="7007265" cy="3557547"/>
             </a:xfrm>
           </p:grpSpPr>
-          <p:pic>
-            <p:nvPicPr>
-              <p:cNvPr id="5" name="Picture 4" descr="A grid of squares with different shades of yellow and white squares&#10;&#10;AI-generated content may be incorrect.">
-                <a:extLst>
-                  <a:ext uri="{FF2B5EF4-FFF2-40B4-BE49-F238E27FC236}">
-                    <a16:creationId xmlns:a16="http://schemas.microsoft.com/office/drawing/2014/main" id="{DCC30411-9FF4-AC1F-CB52-2F8D72A2D09C}"/>
-                  </a:ext>
-                </a:extLst>
-              </p:cNvPr>
-              <p:cNvPicPr>
-                <a:picLocks noChangeAspect="1"/>
-              </p:cNvPicPr>
-              <p:nvPr/>
-            </p:nvPicPr>
-            <p:blipFill>
-              <a:blip r:embed="rId2"/>
-              <a:stretch>
-                <a:fillRect/>
-              </a:stretch>
-            </p:blipFill>
-            <p:spPr>
-              <a:xfrm>
-                <a:off x="2412243" y="1685759"/>
-                <a:ext cx="7772400" cy="4211528"/>
-              </a:xfrm>
-              <a:prstGeom prst="rect">
-                <a:avLst/>
-              </a:prstGeom>
-            </p:spPr>
-          </p:pic>
           <p:sp>
             <p:nvSpPr>
               <p:cNvPr id="21" name="Rectangle 20">
@@ -6008,114 +6481,6 @@
               <a:xfrm>
                 <a:off x="2761785" y="5185316"/>
                 <a:ext cx="7006683" cy="420659"/>
-              </a:xfrm>
-              <a:prstGeom prst="rect">
-                <a:avLst/>
-              </a:prstGeom>
-              <a:solidFill>
-                <a:srgbClr val="7F7F7F">
-                  <a:alpha val="50196"/>
-                </a:srgbClr>
-              </a:solidFill>
-              <a:ln>
-                <a:noFill/>
-              </a:ln>
-            </p:spPr>
-            <p:style>
-              <a:lnRef idx="2">
-                <a:schemeClr val="accent1">
-                  <a:shade val="15000"/>
-                </a:schemeClr>
-              </a:lnRef>
-              <a:fillRef idx="1">
-                <a:schemeClr val="accent1"/>
-              </a:fillRef>
-              <a:effectRef idx="0">
-                <a:schemeClr val="accent1"/>
-              </a:effectRef>
-              <a:fontRef idx="minor">
-                <a:schemeClr val="lt1"/>
-              </a:fontRef>
-            </p:style>
-            <p:txBody>
-              <a:bodyPr rtlCol="0" anchor="ctr"/>
-              <a:lstStyle/>
-              <a:p>
-                <a:pPr algn="ctr"/>
-                <a:endParaRPr lang="en-US"/>
-              </a:p>
-            </p:txBody>
-          </p:sp>
-          <p:sp>
-            <p:nvSpPr>
-              <p:cNvPr id="23" name="Rectangle 22">
-                <a:extLst>
-                  <a:ext uri="{FF2B5EF4-FFF2-40B4-BE49-F238E27FC236}">
-                    <a16:creationId xmlns:a16="http://schemas.microsoft.com/office/drawing/2014/main" id="{049D8E59-EFFC-24E8-93BC-C6B80FC2046F}"/>
-                  </a:ext>
-                </a:extLst>
-              </p:cNvPr>
-              <p:cNvSpPr/>
-              <p:nvPr/>
-            </p:nvSpPr>
-            <p:spPr>
-              <a:xfrm>
-                <a:off x="9318156" y="2503295"/>
-                <a:ext cx="446048" cy="2682021"/>
-              </a:xfrm>
-              <a:prstGeom prst="rect">
-                <a:avLst/>
-              </a:prstGeom>
-              <a:solidFill>
-                <a:srgbClr val="7F7F7F">
-                  <a:alpha val="50196"/>
-                </a:srgbClr>
-              </a:solidFill>
-              <a:ln>
-                <a:noFill/>
-              </a:ln>
-            </p:spPr>
-            <p:style>
-              <a:lnRef idx="2">
-                <a:schemeClr val="accent1">
-                  <a:shade val="15000"/>
-                </a:schemeClr>
-              </a:lnRef>
-              <a:fillRef idx="1">
-                <a:schemeClr val="accent1"/>
-              </a:fillRef>
-              <a:effectRef idx="0">
-                <a:schemeClr val="accent1"/>
-              </a:effectRef>
-              <a:fontRef idx="minor">
-                <a:schemeClr val="lt1"/>
-              </a:fontRef>
-            </p:style>
-            <p:txBody>
-              <a:bodyPr rtlCol="0" anchor="ctr"/>
-              <a:lstStyle/>
-              <a:p>
-                <a:pPr algn="ctr"/>
-                <a:endParaRPr lang="en-US"/>
-              </a:p>
-            </p:txBody>
-          </p:sp>
-          <p:sp>
-            <p:nvSpPr>
-              <p:cNvPr id="24" name="Rectangle 23">
-                <a:extLst>
-                  <a:ext uri="{FF2B5EF4-FFF2-40B4-BE49-F238E27FC236}">
-                    <a16:creationId xmlns:a16="http://schemas.microsoft.com/office/drawing/2014/main" id="{D8B47DC9-7F6B-2AFB-F275-09F56C3B3237}"/>
-                  </a:ext>
-                </a:extLst>
-              </p:cNvPr>
-              <p:cNvSpPr/>
-              <p:nvPr/>
-            </p:nvSpPr>
-            <p:spPr>
-              <a:xfrm>
-                <a:off x="2761784" y="2509654"/>
-                <a:ext cx="446048" cy="2675662"/>
               </a:xfrm>
               <a:prstGeom prst="rect">
                 <a:avLst/>
@@ -6287,7 +6652,7 @@
 </p:sld>
 </file>
 
-<file path=ppt/slides/slide5.xml><?xml version="1.0" encoding="utf-8"?>
+<file path=ppt/slides/slide6.xml><?xml version="1.0" encoding="utf-8"?>
 <p:sld xmlns:a="http://schemas.openxmlformats.org/drawingml/2006/main" xmlns:r="http://schemas.openxmlformats.org/officeDocument/2006/relationships" xmlns:p="http://schemas.openxmlformats.org/presentationml/2006/main">
   <p:cSld>
     <p:spTree>
@@ -6310,6 +6675,36 @@
           <a:chExt cx="0" cy="0"/>
         </a:xfrm>
       </p:grpSpPr>
+      <p:pic>
+        <p:nvPicPr>
+          <p:cNvPr id="9" name="Picture 8">
+            <a:extLst>
+              <a:ext uri="{FF2B5EF4-FFF2-40B4-BE49-F238E27FC236}">
+                <a16:creationId xmlns:a16="http://schemas.microsoft.com/office/drawing/2014/main" id="{5BB3C141-AF2C-7E61-C8DA-A982496F0719}"/>
+              </a:ext>
+            </a:extLst>
+          </p:cNvPr>
+          <p:cNvPicPr>
+            <a:picLocks noChangeAspect="1"/>
+          </p:cNvPicPr>
+          <p:nvPr/>
+        </p:nvPicPr>
+        <p:blipFill>
+          <a:blip r:embed="rId2"/>
+          <a:stretch>
+            <a:fillRect/>
+          </a:stretch>
+        </p:blipFill>
+        <p:spPr>
+          <a:xfrm>
+            <a:off x="2368550" y="1676130"/>
+            <a:ext cx="7772400" cy="4216940"/>
+          </a:xfrm>
+          <a:prstGeom prst="rect">
+            <a:avLst/>
+          </a:prstGeom>
+        </p:spPr>
+      </p:pic>
       <p:sp>
         <p:nvSpPr>
           <p:cNvPr id="2" name="Title 1">
@@ -6352,10 +6747,10 @@
         </p:nvGrpSpPr>
         <p:grpSpPr>
           <a:xfrm>
-            <a:off x="2398059" y="1494430"/>
-            <a:ext cx="7772400" cy="4740573"/>
-            <a:chOff x="2398059" y="1494430"/>
-            <a:chExt cx="7772400" cy="4740573"/>
+            <a:off x="2190757" y="1531685"/>
+            <a:ext cx="7577712" cy="4571714"/>
+            <a:chOff x="2190757" y="1531685"/>
+            <a:chExt cx="7577712" cy="4571714"/>
           </a:xfrm>
         </p:grpSpPr>
         <p:grpSp>
@@ -6372,42 +6767,12 @@
           </p:nvGrpSpPr>
           <p:grpSpPr>
             <a:xfrm>
-              <a:off x="2398059" y="1690688"/>
-              <a:ext cx="7772400" cy="4211528"/>
-              <a:chOff x="2398059" y="1690688"/>
-              <a:chExt cx="7772400" cy="4211528"/>
+              <a:off x="2761784" y="2048428"/>
+              <a:ext cx="7006685" cy="3557547"/>
+              <a:chOff x="2761784" y="2048428"/>
+              <a:chExt cx="7006685" cy="3557547"/>
             </a:xfrm>
           </p:grpSpPr>
-          <p:pic>
-            <p:nvPicPr>
-              <p:cNvPr id="5" name="Picture 4" descr="A grid of squares with different shades of yellow and white squares&#10;&#10;AI-generated content may be incorrect.">
-                <a:extLst>
-                  <a:ext uri="{FF2B5EF4-FFF2-40B4-BE49-F238E27FC236}">
-                    <a16:creationId xmlns:a16="http://schemas.microsoft.com/office/drawing/2014/main" id="{EF604C1A-A3BC-6BF0-B541-5B2C3FA6F37F}"/>
-                  </a:ext>
-                </a:extLst>
-              </p:cNvPr>
-              <p:cNvPicPr>
-                <a:picLocks noChangeAspect="1"/>
-              </p:cNvPicPr>
-              <p:nvPr/>
-            </p:nvPicPr>
-            <p:blipFill>
-              <a:blip r:embed="rId2"/>
-              <a:stretch>
-                <a:fillRect/>
-              </a:stretch>
-            </p:blipFill>
-            <p:spPr>
-              <a:xfrm>
-                <a:off x="2398059" y="1690688"/>
-                <a:ext cx="7772400" cy="4211528"/>
-              </a:xfrm>
-              <a:prstGeom prst="rect">
-                <a:avLst/>
-              </a:prstGeom>
-            </p:spPr>
-          </p:pic>
           <p:sp>
             <p:nvSpPr>
               <p:cNvPr id="21" name="Rectangle 20">
@@ -6530,8 +6895,8 @@
             </p:nvSpPr>
             <p:spPr>
               <a:xfrm>
-                <a:off x="5832088" y="2503295"/>
-                <a:ext cx="3932116" cy="2682022"/>
+                <a:off x="3645366" y="2503295"/>
+                <a:ext cx="6118838" cy="2682022"/>
               </a:xfrm>
               <a:prstGeom prst="rect">
                 <a:avLst/>
@@ -6572,60 +6937,6 @@
           </p:sp>
           <p:sp>
             <p:nvSpPr>
-              <p:cNvPr id="24" name="Rectangle 23">
-                <a:extLst>
-                  <a:ext uri="{FF2B5EF4-FFF2-40B4-BE49-F238E27FC236}">
-                    <a16:creationId xmlns:a16="http://schemas.microsoft.com/office/drawing/2014/main" id="{55390B45-05DB-BB6C-1684-0FF1CACB8F81}"/>
-                  </a:ext>
-                </a:extLst>
-              </p:cNvPr>
-              <p:cNvSpPr/>
-              <p:nvPr/>
-            </p:nvSpPr>
-            <p:spPr>
-              <a:xfrm>
-                <a:off x="2761784" y="2509654"/>
-                <a:ext cx="446048" cy="2635095"/>
-              </a:xfrm>
-              <a:prstGeom prst="rect">
-                <a:avLst/>
-              </a:prstGeom>
-              <a:solidFill>
-                <a:srgbClr val="7F7F7F">
-                  <a:alpha val="50196"/>
-                </a:srgbClr>
-              </a:solidFill>
-              <a:ln>
-                <a:noFill/>
-              </a:ln>
-            </p:spPr>
-            <p:style>
-              <a:lnRef idx="2">
-                <a:schemeClr val="accent1">
-                  <a:shade val="15000"/>
-                </a:schemeClr>
-              </a:lnRef>
-              <a:fillRef idx="1">
-                <a:schemeClr val="accent1"/>
-              </a:fillRef>
-              <a:effectRef idx="0">
-                <a:schemeClr val="accent1"/>
-              </a:effectRef>
-              <a:fontRef idx="minor">
-                <a:schemeClr val="lt1"/>
-              </a:fontRef>
-            </p:style>
-            <p:txBody>
-              <a:bodyPr rtlCol="0" anchor="ctr"/>
-              <a:lstStyle/>
-              <a:p>
-                <a:pPr algn="ctr"/>
-                <a:endParaRPr lang="en-US"/>
-              </a:p>
-            </p:txBody>
-          </p:sp>
-          <p:sp>
-            <p:nvSpPr>
               <p:cNvPr id="26" name="Rectangle 25">
                 <a:extLst>
                   <a:ext uri="{FF2B5EF4-FFF2-40B4-BE49-F238E27FC236}">
@@ -6638,8 +6949,8 @@
             </p:nvSpPr>
             <p:spPr>
               <a:xfrm>
-                <a:off x="3207832" y="2503294"/>
-                <a:ext cx="2624256" cy="2664017"/>
+                <a:off x="2774950" y="2503294"/>
+                <a:ext cx="857250" cy="2664017"/>
               </a:xfrm>
               <a:prstGeom prst="rect">
                 <a:avLst/>
@@ -6691,6 +7002,515 @@
           </p:nvSpPr>
           <p:spPr>
             <a:xfrm>
+              <a:off x="2289049" y="1531685"/>
+              <a:ext cx="2064933" cy="369332"/>
+            </a:xfrm>
+            <a:prstGeom prst="rect">
+              <a:avLst/>
+            </a:prstGeom>
+            <a:noFill/>
+          </p:spPr>
+          <p:txBody>
+            <a:bodyPr wrap="square" rtlCol="0">
+              <a:spAutoFit/>
+            </a:bodyPr>
+            <a:lstStyle/>
+            <a:p>
+              <a:r>
+                <a:rPr lang="en-US" dirty="0"/>
+                <a:t>Arm for recording</a:t>
+              </a:r>
+            </a:p>
+          </p:txBody>
+        </p:sp>
+        <p:sp>
+          <p:nvSpPr>
+            <p:cNvPr id="4" name="TextBox 3">
+              <a:extLst>
+                <a:ext uri="{FF2B5EF4-FFF2-40B4-BE49-F238E27FC236}">
+                  <a16:creationId xmlns:a16="http://schemas.microsoft.com/office/drawing/2014/main" id="{B0430330-2094-A3A0-1E64-DF29C7E900C8}"/>
+                </a:ext>
+              </a:extLst>
+            </p:cNvPr>
+            <p:cNvSpPr txBox="1"/>
+            <p:nvPr/>
+          </p:nvSpPr>
+          <p:spPr>
+            <a:xfrm>
+              <a:off x="2190757" y="5734067"/>
+              <a:ext cx="2064933" cy="369332"/>
+            </a:xfrm>
+            <a:prstGeom prst="rect">
+              <a:avLst/>
+            </a:prstGeom>
+            <a:noFill/>
+          </p:spPr>
+          <p:txBody>
+            <a:bodyPr wrap="square" rtlCol="0">
+              <a:spAutoFit/>
+            </a:bodyPr>
+            <a:lstStyle/>
+            <a:p>
+              <a:r>
+                <a:rPr lang="en-US" dirty="0"/>
+                <a:t>Chan 1</a:t>
+              </a:r>
+            </a:p>
+          </p:txBody>
+        </p:sp>
+        <p:sp>
+          <p:nvSpPr>
+            <p:cNvPr id="6" name="TextBox 5">
+              <a:extLst>
+                <a:ext uri="{FF2B5EF4-FFF2-40B4-BE49-F238E27FC236}">
+                  <a16:creationId xmlns:a16="http://schemas.microsoft.com/office/drawing/2014/main" id="{F2A7F881-B94C-01CD-DECF-238DB98A4CBC}"/>
+                </a:ext>
+              </a:extLst>
+            </p:cNvPr>
+            <p:cNvSpPr txBox="1"/>
+            <p:nvPr/>
+          </p:nvSpPr>
+          <p:spPr>
+            <a:xfrm>
+              <a:off x="3302724" y="5734067"/>
+              <a:ext cx="2064933" cy="369332"/>
+            </a:xfrm>
+            <a:prstGeom prst="rect">
+              <a:avLst/>
+            </a:prstGeom>
+            <a:noFill/>
+          </p:spPr>
+          <p:txBody>
+            <a:bodyPr wrap="square" rtlCol="0">
+              <a:spAutoFit/>
+            </a:bodyPr>
+            <a:lstStyle/>
+            <a:p>
+              <a:r>
+                <a:rPr lang="en-US" dirty="0"/>
+                <a:t>Chan 2</a:t>
+              </a:r>
+            </a:p>
+          </p:txBody>
+        </p:sp>
+      </p:grpSp>
+    </p:spTree>
+    <p:extLst>
+      <p:ext uri="{BB962C8B-B14F-4D97-AF65-F5344CB8AC3E}">
+        <p14:creationId xmlns:p14="http://schemas.microsoft.com/office/powerpoint/2010/main" val="3420841610"/>
+      </p:ext>
+    </p:extLst>
+  </p:cSld>
+  <p:clrMapOvr>
+    <a:masterClrMapping/>
+  </p:clrMapOvr>
+</p:sld>
+</file>
+
+<file path=ppt/slides/slide7.xml><?xml version="1.0" encoding="utf-8"?>
+<p:sld xmlns:a="http://schemas.openxmlformats.org/drawingml/2006/main" xmlns:r="http://schemas.openxmlformats.org/officeDocument/2006/relationships" xmlns:p="http://schemas.openxmlformats.org/presentationml/2006/main">
+  <p:cSld>
+    <p:spTree>
+      <p:nvGrpSpPr>
+        <p:cNvPr id="1" name="">
+          <a:extLst>
+            <a:ext uri="{FF2B5EF4-FFF2-40B4-BE49-F238E27FC236}">
+              <a16:creationId xmlns:a16="http://schemas.microsoft.com/office/drawing/2014/main" id="{70D28F1C-1F09-0D7F-1B21-0DD022254854}"/>
+            </a:ext>
+          </a:extLst>
+        </p:cNvPr>
+        <p:cNvGrpSpPr/>
+        <p:nvPr/>
+      </p:nvGrpSpPr>
+      <p:grpSpPr>
+        <a:xfrm>
+          <a:off x="0" y="0"/>
+          <a:ext cx="0" cy="0"/>
+          <a:chOff x="0" y="0"/>
+          <a:chExt cx="0" cy="0"/>
+        </a:xfrm>
+      </p:grpSpPr>
+      <p:pic>
+        <p:nvPicPr>
+          <p:cNvPr id="9" name="Picture 8">
+            <a:extLst>
+              <a:ext uri="{FF2B5EF4-FFF2-40B4-BE49-F238E27FC236}">
+                <a16:creationId xmlns:a16="http://schemas.microsoft.com/office/drawing/2014/main" id="{11A474C5-A652-5507-F31C-65E7739750DF}"/>
+              </a:ext>
+            </a:extLst>
+          </p:cNvPr>
+          <p:cNvPicPr>
+            <a:picLocks noChangeAspect="1"/>
+          </p:cNvPicPr>
+          <p:nvPr/>
+        </p:nvPicPr>
+        <p:blipFill>
+          <a:blip r:embed="rId2"/>
+          <a:stretch>
+            <a:fillRect/>
+          </a:stretch>
+        </p:blipFill>
+        <p:spPr>
+          <a:xfrm>
+            <a:off x="2368550" y="1676130"/>
+            <a:ext cx="7772400" cy="4216940"/>
+          </a:xfrm>
+          <a:prstGeom prst="rect">
+            <a:avLst/>
+          </a:prstGeom>
+        </p:spPr>
+      </p:pic>
+      <p:sp>
+        <p:nvSpPr>
+          <p:cNvPr id="2" name="Title 1">
+            <a:extLst>
+              <a:ext uri="{FF2B5EF4-FFF2-40B4-BE49-F238E27FC236}">
+                <a16:creationId xmlns:a16="http://schemas.microsoft.com/office/drawing/2014/main" id="{D2205A64-1687-4530-AA1D-68112BE1552D}"/>
+              </a:ext>
+            </a:extLst>
+          </p:cNvPr>
+          <p:cNvSpPr>
+            <a:spLocks noGrp="1"/>
+          </p:cNvSpPr>
+          <p:nvPr>
+            <p:ph type="title"/>
+          </p:nvPr>
+        </p:nvSpPr>
+        <p:spPr/>
+        <p:txBody>
+          <a:bodyPr/>
+          <a:lstStyle/>
+          <a:p>
+            <a:r>
+              <a:rPr lang="en-US" dirty="0"/>
+              <a:t>REC page</a:t>
+            </a:r>
+          </a:p>
+        </p:txBody>
+      </p:sp>
+      <p:grpSp>
+        <p:nvGrpSpPr>
+          <p:cNvPr id="8" name="Group 7">
+            <a:extLst>
+              <a:ext uri="{FF2B5EF4-FFF2-40B4-BE49-F238E27FC236}">
+                <a16:creationId xmlns:a16="http://schemas.microsoft.com/office/drawing/2014/main" id="{4567EE29-9A80-75F9-A924-7C0C04DAA7B2}"/>
+              </a:ext>
+            </a:extLst>
+          </p:cNvPr>
+          <p:cNvGrpSpPr/>
+          <p:nvPr/>
+        </p:nvGrpSpPr>
+        <p:grpSpPr>
+          <a:xfrm>
+            <a:off x="2761784" y="1494430"/>
+            <a:ext cx="7006685" cy="4722975"/>
+            <a:chOff x="2761784" y="1494430"/>
+            <a:chExt cx="7006685" cy="4722975"/>
+          </a:xfrm>
+        </p:grpSpPr>
+        <p:grpSp>
+          <p:nvGrpSpPr>
+            <p:cNvPr id="30" name="Group 29">
+              <a:extLst>
+                <a:ext uri="{FF2B5EF4-FFF2-40B4-BE49-F238E27FC236}">
+                  <a16:creationId xmlns:a16="http://schemas.microsoft.com/office/drawing/2014/main" id="{355E1FE0-6E47-09D5-7230-0F8FD8024C09}"/>
+                </a:ext>
+              </a:extLst>
+            </p:cNvPr>
+            <p:cNvGrpSpPr/>
+            <p:nvPr/>
+          </p:nvGrpSpPr>
+          <p:grpSpPr>
+            <a:xfrm>
+              <a:off x="2761784" y="2048428"/>
+              <a:ext cx="7006685" cy="3557547"/>
+              <a:chOff x="2761784" y="2048428"/>
+              <a:chExt cx="7006685" cy="3557547"/>
+            </a:xfrm>
+          </p:grpSpPr>
+          <p:sp>
+            <p:nvSpPr>
+              <p:cNvPr id="21" name="Rectangle 20">
+                <a:extLst>
+                  <a:ext uri="{FF2B5EF4-FFF2-40B4-BE49-F238E27FC236}">
+                    <a16:creationId xmlns:a16="http://schemas.microsoft.com/office/drawing/2014/main" id="{2A026836-7078-D906-1E21-6F79B698A5EA}"/>
+                  </a:ext>
+                </a:extLst>
+              </p:cNvPr>
+              <p:cNvSpPr/>
+              <p:nvPr/>
+            </p:nvSpPr>
+            <p:spPr>
+              <a:xfrm>
+                <a:off x="2761784" y="2048428"/>
+                <a:ext cx="7006685" cy="461226"/>
+              </a:xfrm>
+              <a:prstGeom prst="rect">
+                <a:avLst/>
+              </a:prstGeom>
+              <a:solidFill>
+                <a:srgbClr val="7F7F7F">
+                  <a:alpha val="50196"/>
+                </a:srgbClr>
+              </a:solidFill>
+              <a:ln>
+                <a:noFill/>
+              </a:ln>
+            </p:spPr>
+            <p:style>
+              <a:lnRef idx="2">
+                <a:schemeClr val="accent1">
+                  <a:shade val="15000"/>
+                </a:schemeClr>
+              </a:lnRef>
+              <a:fillRef idx="1">
+                <a:schemeClr val="accent1"/>
+              </a:fillRef>
+              <a:effectRef idx="0">
+                <a:schemeClr val="accent1"/>
+              </a:effectRef>
+              <a:fontRef idx="minor">
+                <a:schemeClr val="lt1"/>
+              </a:fontRef>
+            </p:style>
+            <p:txBody>
+              <a:bodyPr rtlCol="0" anchor="ctr"/>
+              <a:lstStyle/>
+              <a:p>
+                <a:pPr algn="ctr"/>
+                <a:endParaRPr lang="en-US" dirty="0"/>
+              </a:p>
+            </p:txBody>
+          </p:sp>
+          <p:sp>
+            <p:nvSpPr>
+              <p:cNvPr id="22" name="Rectangle 21">
+                <a:extLst>
+                  <a:ext uri="{FF2B5EF4-FFF2-40B4-BE49-F238E27FC236}">
+                    <a16:creationId xmlns:a16="http://schemas.microsoft.com/office/drawing/2014/main" id="{F43E731B-F5BD-AE09-0A6A-2FAFAB7E2E00}"/>
+                  </a:ext>
+                </a:extLst>
+              </p:cNvPr>
+              <p:cNvSpPr/>
+              <p:nvPr/>
+            </p:nvSpPr>
+            <p:spPr>
+              <a:xfrm>
+                <a:off x="2761785" y="5185316"/>
+                <a:ext cx="7006683" cy="420659"/>
+              </a:xfrm>
+              <a:prstGeom prst="rect">
+                <a:avLst/>
+              </a:prstGeom>
+              <a:solidFill>
+                <a:srgbClr val="7F7F7F">
+                  <a:alpha val="50196"/>
+                </a:srgbClr>
+              </a:solidFill>
+              <a:ln>
+                <a:noFill/>
+              </a:ln>
+            </p:spPr>
+            <p:style>
+              <a:lnRef idx="2">
+                <a:schemeClr val="accent1">
+                  <a:shade val="15000"/>
+                </a:schemeClr>
+              </a:lnRef>
+              <a:fillRef idx="1">
+                <a:schemeClr val="accent1"/>
+              </a:fillRef>
+              <a:effectRef idx="0">
+                <a:schemeClr val="accent1"/>
+              </a:effectRef>
+              <a:fontRef idx="minor">
+                <a:schemeClr val="lt1"/>
+              </a:fontRef>
+            </p:style>
+            <p:txBody>
+              <a:bodyPr rtlCol="0" anchor="ctr"/>
+              <a:lstStyle/>
+              <a:p>
+                <a:pPr algn="ctr"/>
+                <a:endParaRPr lang="en-US"/>
+              </a:p>
+            </p:txBody>
+          </p:sp>
+          <p:sp>
+            <p:nvSpPr>
+              <p:cNvPr id="23" name="Rectangle 22">
+                <a:extLst>
+                  <a:ext uri="{FF2B5EF4-FFF2-40B4-BE49-F238E27FC236}">
+                    <a16:creationId xmlns:a16="http://schemas.microsoft.com/office/drawing/2014/main" id="{19637D8A-EBCE-444D-F261-EBFB2C61429E}"/>
+                  </a:ext>
+                </a:extLst>
+              </p:cNvPr>
+              <p:cNvSpPr/>
+              <p:nvPr/>
+            </p:nvSpPr>
+            <p:spPr>
+              <a:xfrm>
+                <a:off x="5832088" y="2503295"/>
+                <a:ext cx="3932116" cy="2682022"/>
+              </a:xfrm>
+              <a:prstGeom prst="rect">
+                <a:avLst/>
+              </a:prstGeom>
+              <a:solidFill>
+                <a:srgbClr val="7F7F7F">
+                  <a:alpha val="50196"/>
+                </a:srgbClr>
+              </a:solidFill>
+              <a:ln>
+                <a:noFill/>
+              </a:ln>
+            </p:spPr>
+            <p:style>
+              <a:lnRef idx="2">
+                <a:schemeClr val="accent1">
+                  <a:shade val="15000"/>
+                </a:schemeClr>
+              </a:lnRef>
+              <a:fillRef idx="1">
+                <a:schemeClr val="accent1"/>
+              </a:fillRef>
+              <a:effectRef idx="0">
+                <a:schemeClr val="accent1"/>
+              </a:effectRef>
+              <a:fontRef idx="minor">
+                <a:schemeClr val="lt1"/>
+              </a:fontRef>
+            </p:style>
+            <p:txBody>
+              <a:bodyPr rtlCol="0" anchor="ctr"/>
+              <a:lstStyle/>
+              <a:p>
+                <a:pPr algn="ctr"/>
+                <a:endParaRPr lang="en-US" dirty="0"/>
+              </a:p>
+            </p:txBody>
+          </p:sp>
+          <p:sp>
+            <p:nvSpPr>
+              <p:cNvPr id="24" name="Rectangle 23">
+                <a:extLst>
+                  <a:ext uri="{FF2B5EF4-FFF2-40B4-BE49-F238E27FC236}">
+                    <a16:creationId xmlns:a16="http://schemas.microsoft.com/office/drawing/2014/main" id="{D3456FEE-43DF-6C25-4B7D-8057E35D1313}"/>
+                  </a:ext>
+                </a:extLst>
+              </p:cNvPr>
+              <p:cNvSpPr/>
+              <p:nvPr/>
+            </p:nvSpPr>
+            <p:spPr>
+              <a:xfrm>
+                <a:off x="2761784" y="2509654"/>
+                <a:ext cx="883116" cy="2672216"/>
+              </a:xfrm>
+              <a:prstGeom prst="rect">
+                <a:avLst/>
+              </a:prstGeom>
+              <a:solidFill>
+                <a:srgbClr val="7F7F7F">
+                  <a:alpha val="50196"/>
+                </a:srgbClr>
+              </a:solidFill>
+              <a:ln>
+                <a:noFill/>
+              </a:ln>
+            </p:spPr>
+            <p:style>
+              <a:lnRef idx="2">
+                <a:schemeClr val="accent1">
+                  <a:shade val="15000"/>
+                </a:schemeClr>
+              </a:lnRef>
+              <a:fillRef idx="1">
+                <a:schemeClr val="accent1"/>
+              </a:fillRef>
+              <a:effectRef idx="0">
+                <a:schemeClr val="accent1"/>
+              </a:effectRef>
+              <a:fontRef idx="minor">
+                <a:schemeClr val="lt1"/>
+              </a:fontRef>
+            </p:style>
+            <p:txBody>
+              <a:bodyPr rtlCol="0" anchor="ctr"/>
+              <a:lstStyle/>
+              <a:p>
+                <a:pPr algn="ctr"/>
+                <a:endParaRPr lang="en-US" dirty="0"/>
+              </a:p>
+            </p:txBody>
+          </p:sp>
+          <p:sp>
+            <p:nvSpPr>
+              <p:cNvPr id="26" name="Rectangle 25">
+                <a:extLst>
+                  <a:ext uri="{FF2B5EF4-FFF2-40B4-BE49-F238E27FC236}">
+                    <a16:creationId xmlns:a16="http://schemas.microsoft.com/office/drawing/2014/main" id="{D531FA4D-9F28-6A4E-6EFB-E9FA18763F47}"/>
+                  </a:ext>
+                </a:extLst>
+              </p:cNvPr>
+              <p:cNvSpPr/>
+              <p:nvPr/>
+            </p:nvSpPr>
+            <p:spPr>
+              <a:xfrm>
+                <a:off x="3644900" y="2503294"/>
+                <a:ext cx="2187188" cy="2664017"/>
+              </a:xfrm>
+              <a:prstGeom prst="rect">
+                <a:avLst/>
+              </a:prstGeom>
+              <a:noFill/>
+              <a:ln w="38100">
+                <a:solidFill>
+                  <a:schemeClr val="accent5"/>
+                </a:solidFill>
+              </a:ln>
+            </p:spPr>
+            <p:style>
+              <a:lnRef idx="2">
+                <a:schemeClr val="accent1">
+                  <a:shade val="15000"/>
+                </a:schemeClr>
+              </a:lnRef>
+              <a:fillRef idx="1">
+                <a:schemeClr val="accent1"/>
+              </a:fillRef>
+              <a:effectRef idx="0">
+                <a:schemeClr val="accent1"/>
+              </a:effectRef>
+              <a:fontRef idx="minor">
+                <a:schemeClr val="lt1"/>
+              </a:fontRef>
+            </p:style>
+            <p:txBody>
+              <a:bodyPr rtlCol="0" anchor="ctr"/>
+              <a:lstStyle/>
+              <a:p>
+                <a:pPr algn="ctr"/>
+                <a:endParaRPr lang="en-US" dirty="0"/>
+              </a:p>
+            </p:txBody>
+          </p:sp>
+        </p:grpSp>
+        <p:sp>
+          <p:nvSpPr>
+            <p:cNvPr id="3" name="TextBox 2">
+              <a:extLst>
+                <a:ext uri="{FF2B5EF4-FFF2-40B4-BE49-F238E27FC236}">
+                  <a16:creationId xmlns:a16="http://schemas.microsoft.com/office/drawing/2014/main" id="{79644EC9-007E-629F-3EE4-44017FF5C949}"/>
+                </a:ext>
+              </a:extLst>
+            </p:cNvPr>
+            <p:cNvSpPr txBox="1"/>
+            <p:nvPr/>
+          </p:nvSpPr>
+          <p:spPr>
+            <a:xfrm>
               <a:off x="4031067" y="1494430"/>
               <a:ext cx="2064933" cy="369332"/>
             </a:xfrm>
@@ -6717,7 +7537,7 @@
             <p:cNvPr id="4" name="TextBox 3">
               <a:extLst>
                 <a:ext uri="{FF2B5EF4-FFF2-40B4-BE49-F238E27FC236}">
-                  <a16:creationId xmlns:a16="http://schemas.microsoft.com/office/drawing/2014/main" id="{B0430330-2094-A3A0-1E64-DF29C7E900C8}"/>
+                  <a16:creationId xmlns:a16="http://schemas.microsoft.com/office/drawing/2014/main" id="{5513ADF1-F20D-6518-A777-D63840C9869A}"/>
                 </a:ext>
               </a:extLst>
             </p:cNvPr>
@@ -6726,7 +7546,7 @@
           </p:nvSpPr>
           <p:spPr>
             <a:xfrm>
-              <a:off x="2815762" y="5865671"/>
+              <a:off x="3545668" y="5846673"/>
               <a:ext cx="2064933" cy="369332"/>
             </a:xfrm>
             <a:prstGeom prst="rect">
@@ -6752,7 +7572,7 @@
             <p:cNvPr id="6" name="TextBox 5">
               <a:extLst>
                 <a:ext uri="{FF2B5EF4-FFF2-40B4-BE49-F238E27FC236}">
-                  <a16:creationId xmlns:a16="http://schemas.microsoft.com/office/drawing/2014/main" id="{F2A7F881-B94C-01CD-DECF-238DB98A4CBC}"/>
+                  <a16:creationId xmlns:a16="http://schemas.microsoft.com/office/drawing/2014/main" id="{F349BBD5-6073-F581-2E04-22D5B3CACE01}"/>
                 </a:ext>
               </a:extLst>
             </p:cNvPr>
@@ -6761,7 +7581,7 @@
           </p:nvSpPr>
           <p:spPr>
             <a:xfrm>
-              <a:off x="5593616" y="5865671"/>
+              <a:off x="5327907" y="5846673"/>
               <a:ext cx="2064933" cy="369332"/>
             </a:xfrm>
             <a:prstGeom prst="rect">
@@ -6787,7 +7607,7 @@
             <p:cNvPr id="7" name="TextBox 6">
               <a:extLst>
                 <a:ext uri="{FF2B5EF4-FFF2-40B4-BE49-F238E27FC236}">
-                  <a16:creationId xmlns:a16="http://schemas.microsoft.com/office/drawing/2014/main" id="{3A872BB0-65E2-8166-F892-553D1259C384}"/>
+                  <a16:creationId xmlns:a16="http://schemas.microsoft.com/office/drawing/2014/main" id="{5CB5BE79-51D3-943A-D6A1-03C3283FF76F}"/>
                 </a:ext>
               </a:extLst>
             </p:cNvPr>
@@ -6796,7 +7616,7 @@
           </p:nvSpPr>
           <p:spPr>
             <a:xfrm>
-              <a:off x="3978059" y="5865671"/>
+              <a:off x="4031067" y="5848073"/>
               <a:ext cx="2064933" cy="369332"/>
             </a:xfrm>
             <a:prstGeom prst="rect">
@@ -6821,7 +7641,7 @@
     </p:spTree>
     <p:extLst>
       <p:ext uri="{BB962C8B-B14F-4D97-AF65-F5344CB8AC3E}">
-        <p14:creationId xmlns:p14="http://schemas.microsoft.com/office/powerpoint/2010/main" val="3420841610"/>
+        <p14:creationId xmlns:p14="http://schemas.microsoft.com/office/powerpoint/2010/main" val="1545590975"/>
       </p:ext>
     </p:extLst>
   </p:cSld>
@@ -6831,7 +7651,7 @@
 </p:sld>
 </file>
 
-<file path=ppt/slides/slide6.xml><?xml version="1.0" encoding="utf-8"?>
+<file path=ppt/slides/slide8.xml><?xml version="1.0" encoding="utf-8"?>
 <p:sld xmlns:a="http://schemas.openxmlformats.org/drawingml/2006/main" xmlns:r="http://schemas.openxmlformats.org/officeDocument/2006/relationships" xmlns:p="http://schemas.openxmlformats.org/presentationml/2006/main">
   <p:cSld>
     <p:spTree>
@@ -6854,6 +7674,36 @@
           <a:chExt cx="0" cy="0"/>
         </a:xfrm>
       </p:grpSpPr>
+      <p:pic>
+        <p:nvPicPr>
+          <p:cNvPr id="6" name="Picture 5">
+            <a:extLst>
+              <a:ext uri="{FF2B5EF4-FFF2-40B4-BE49-F238E27FC236}">
+                <a16:creationId xmlns:a16="http://schemas.microsoft.com/office/drawing/2014/main" id="{599393FC-136A-1E4E-9DC2-65D3ADE526EA}"/>
+              </a:ext>
+            </a:extLst>
+          </p:cNvPr>
+          <p:cNvPicPr>
+            <a:picLocks noChangeAspect="1"/>
+          </p:cNvPicPr>
+          <p:nvPr/>
+        </p:nvPicPr>
+        <p:blipFill>
+          <a:blip r:embed="rId2"/>
+          <a:stretch>
+            <a:fillRect/>
+          </a:stretch>
+        </p:blipFill>
+        <p:spPr>
+          <a:xfrm>
+            <a:off x="2387600" y="1669780"/>
+            <a:ext cx="7772400" cy="4216940"/>
+          </a:xfrm>
+          <a:prstGeom prst="rect">
+            <a:avLst/>
+          </a:prstGeom>
+        </p:spPr>
+      </p:pic>
       <p:sp>
         <p:nvSpPr>
           <p:cNvPr id="2" name="Title 1">
@@ -6896,10 +7746,10 @@
         </p:nvGrpSpPr>
         <p:grpSpPr>
           <a:xfrm>
-            <a:off x="2398059" y="1454279"/>
-            <a:ext cx="7772400" cy="4447937"/>
-            <a:chOff x="2398059" y="1454279"/>
-            <a:chExt cx="7772400" cy="4447937"/>
+            <a:off x="2757519" y="1454279"/>
+            <a:ext cx="7010950" cy="4151696"/>
+            <a:chOff x="2757519" y="1454279"/>
+            <a:chExt cx="7010950" cy="4151696"/>
           </a:xfrm>
         </p:grpSpPr>
         <p:grpSp>
@@ -6916,42 +7766,12 @@
           </p:nvGrpSpPr>
           <p:grpSpPr>
             <a:xfrm>
-              <a:off x="2398059" y="1690688"/>
-              <a:ext cx="7772400" cy="4211528"/>
-              <a:chOff x="2398059" y="1690688"/>
-              <a:chExt cx="7772400" cy="4211528"/>
+              <a:off x="2757519" y="2048428"/>
+              <a:ext cx="7010950" cy="3557547"/>
+              <a:chOff x="2757519" y="2048428"/>
+              <a:chExt cx="7010950" cy="3557547"/>
             </a:xfrm>
           </p:grpSpPr>
-          <p:pic>
-            <p:nvPicPr>
-              <p:cNvPr id="5" name="Picture 4" descr="A grid of squares with different shades of yellow and white squares&#10;&#10;AI-generated content may be incorrect.">
-                <a:extLst>
-                  <a:ext uri="{FF2B5EF4-FFF2-40B4-BE49-F238E27FC236}">
-                    <a16:creationId xmlns:a16="http://schemas.microsoft.com/office/drawing/2014/main" id="{519A4BA0-8861-E4FF-B571-5CEF793F3AB7}"/>
-                  </a:ext>
-                </a:extLst>
-              </p:cNvPr>
-              <p:cNvPicPr>
-                <a:picLocks noChangeAspect="1"/>
-              </p:cNvPicPr>
-              <p:nvPr/>
-            </p:nvPicPr>
-            <p:blipFill>
-              <a:blip r:embed="rId2"/>
-              <a:stretch>
-                <a:fillRect/>
-              </a:stretch>
-            </p:blipFill>
-            <p:spPr>
-              <a:xfrm>
-                <a:off x="2398059" y="1690688"/>
-                <a:ext cx="7772400" cy="4211528"/>
-              </a:xfrm>
-              <a:prstGeom prst="rect">
-                <a:avLst/>
-              </a:prstGeom>
-            </p:spPr>
-          </p:pic>
           <p:sp>
             <p:nvSpPr>
               <p:cNvPr id="21" name="Rectangle 20">
@@ -7128,7 +7948,7 @@
             </p:nvSpPr>
             <p:spPr>
               <a:xfrm>
-                <a:off x="2761783" y="2509654"/>
+                <a:off x="2757519" y="2495193"/>
                 <a:ext cx="3072163" cy="2690124"/>
               </a:xfrm>
               <a:prstGeom prst="rect">
@@ -7183,7 +8003,7 @@
             <p:spPr>
               <a:xfrm>
                 <a:off x="5838211" y="2495192"/>
-                <a:ext cx="446048" cy="2664017"/>
+                <a:ext cx="446048" cy="2690123"/>
               </a:xfrm>
               <a:prstGeom prst="rect">
                 <a:avLst/>
@@ -7270,7 +8090,7 @@
 </p:sld>
 </file>
 
-<file path=ppt/slides/slide7.xml><?xml version="1.0" encoding="utf-8"?>
+<file path=ppt/slides/slide9.xml><?xml version="1.0" encoding="utf-8"?>
 <p:sld xmlns:a="http://schemas.openxmlformats.org/drawingml/2006/main" xmlns:r="http://schemas.openxmlformats.org/officeDocument/2006/relationships" xmlns:p="http://schemas.openxmlformats.org/presentationml/2006/main">
   <p:cSld>
     <p:spTree>
@@ -7293,6 +8113,36 @@
           <a:chExt cx="0" cy="0"/>
         </a:xfrm>
       </p:grpSpPr>
+      <p:pic>
+        <p:nvPicPr>
+          <p:cNvPr id="6" name="Picture 5">
+            <a:extLst>
+              <a:ext uri="{FF2B5EF4-FFF2-40B4-BE49-F238E27FC236}">
+                <a16:creationId xmlns:a16="http://schemas.microsoft.com/office/drawing/2014/main" id="{112DBD4A-65F8-3BD3-A71D-4CF11EB39561}"/>
+              </a:ext>
+            </a:extLst>
+          </p:cNvPr>
+          <p:cNvPicPr>
+            <a:picLocks noChangeAspect="1"/>
+          </p:cNvPicPr>
+          <p:nvPr/>
+        </p:nvPicPr>
+        <p:blipFill>
+          <a:blip r:embed="rId2"/>
+          <a:stretch>
+            <a:fillRect/>
+          </a:stretch>
+        </p:blipFill>
+        <p:spPr>
+          <a:xfrm>
+            <a:off x="2387600" y="1695180"/>
+            <a:ext cx="7772400" cy="4216940"/>
+          </a:xfrm>
+          <a:prstGeom prst="rect">
+            <a:avLst/>
+          </a:prstGeom>
+        </p:spPr>
+      </p:pic>
       <p:sp>
         <p:nvSpPr>
           <p:cNvPr id="2" name="Title 1">
@@ -7335,10 +8185,10 @@
         </p:nvGrpSpPr>
         <p:grpSpPr>
           <a:xfrm>
-            <a:off x="2398059" y="1488608"/>
-            <a:ext cx="7772400" cy="4660443"/>
-            <a:chOff x="2398059" y="1488608"/>
-            <a:chExt cx="7772400" cy="4660443"/>
+            <a:off x="2761784" y="1488608"/>
+            <a:ext cx="7006685" cy="4660443"/>
+            <a:chOff x="2761784" y="1488608"/>
+            <a:chExt cx="7006685" cy="4660443"/>
           </a:xfrm>
         </p:grpSpPr>
         <p:grpSp>
@@ -7355,42 +8205,12 @@
           </p:nvGrpSpPr>
           <p:grpSpPr>
             <a:xfrm>
-              <a:off x="2398059" y="1690688"/>
-              <a:ext cx="7772400" cy="4211528"/>
-              <a:chOff x="2398059" y="1690688"/>
-              <a:chExt cx="7772400" cy="4211528"/>
+              <a:off x="2761784" y="2048428"/>
+              <a:ext cx="7006685" cy="3557547"/>
+              <a:chOff x="2761784" y="2048428"/>
+              <a:chExt cx="7006685" cy="3557547"/>
             </a:xfrm>
           </p:grpSpPr>
-          <p:pic>
-            <p:nvPicPr>
-              <p:cNvPr id="5" name="Picture 4" descr="A grid of squares with different shades of yellow and white squares&#10;&#10;AI-generated content may be incorrect.">
-                <a:extLst>
-                  <a:ext uri="{FF2B5EF4-FFF2-40B4-BE49-F238E27FC236}">
-                    <a16:creationId xmlns:a16="http://schemas.microsoft.com/office/drawing/2014/main" id="{8241CF04-7029-945C-4669-F7858E9553B8}"/>
-                  </a:ext>
-                </a:extLst>
-              </p:cNvPr>
-              <p:cNvPicPr>
-                <a:picLocks noChangeAspect="1"/>
-              </p:cNvPicPr>
-              <p:nvPr/>
-            </p:nvPicPr>
-            <p:blipFill>
-              <a:blip r:embed="rId2"/>
-              <a:stretch>
-                <a:fillRect/>
-              </a:stretch>
-            </p:blipFill>
-            <p:spPr>
-              <a:xfrm>
-                <a:off x="2398059" y="1690688"/>
-                <a:ext cx="7772400" cy="4211528"/>
-              </a:xfrm>
-              <a:prstGeom prst="rect">
-                <a:avLst/>
-              </a:prstGeom>
-            </p:spPr>
-          </p:pic>
           <p:sp>
             <p:nvSpPr>
               <p:cNvPr id="21" name="Rectangle 20">
@@ -7568,7 +8388,7 @@
             <p:spPr>
               <a:xfrm>
                 <a:off x="2761784" y="2509654"/>
-                <a:ext cx="3512088" cy="2664017"/>
+                <a:ext cx="3512088" cy="2675661"/>
               </a:xfrm>
               <a:prstGeom prst="rect">
                 <a:avLst/>
@@ -7603,7 +8423,7 @@
               <a:lstStyle/>
               <a:p>
                 <a:pPr algn="ctr"/>
-                <a:endParaRPr lang="en-US"/>
+                <a:endParaRPr lang="en-US" dirty="0"/>
               </a:p>
             </p:txBody>
           </p:sp>

</xml_diff>